<commit_message>
feat: tipografia do Metodo LAP no deck e rodape sem a marca do cliente
- Playfair Display nos titulos e numerais, DM Sans no corpo e rotulos
- letter-spacing nos rotulos pequenos, conforme o sistema LAP
- rodape passa a trazer o nome do treinamento no lugar de MAN MOTORS S.A.

Co-Authored-By: Claude Opus 5 <noreply@anthropic.com>
</commit_message>
<xml_diff>
--- a/slides-venda-consultiva-vap.pptx
+++ b/slides-venda-consultiva-vap.pptx
@@ -1746,7 +1746,7 @@
                 <a:solidFill>
                   <a:srgbClr val="151210"/>
                 </a:solidFill>
-                <a:latin typeface="Poppins" pitchFamily="34" charset="0"/>
+                <a:latin typeface="Playfair Display" pitchFamily="34" charset="0"/>
                 <a:ea typeface="Arial" pitchFamily="34" charset="-122"/>
                 <a:cs typeface="Arial" pitchFamily="34" charset="-120"/>
               </a:rPr>
@@ -1785,7 +1785,7 @@
                 <a:solidFill>
                   <a:srgbClr val="151210"/>
                 </a:solidFill>
-                <a:latin typeface="Poppins" pitchFamily="34" charset="0"/>
+                <a:latin typeface="Playfair Display" pitchFamily="34" charset="0"/>
                 <a:ea typeface="Arial" pitchFamily="34" charset="-122"/>
                 <a:cs typeface="Arial" pitchFamily="34" charset="-120"/>
               </a:rPr>
@@ -1853,7 +1853,7 @@
                 <a:solidFill>
                   <a:srgbClr val="151210"/>
                 </a:solidFill>
-                <a:latin typeface="Poppins" pitchFamily="34" charset="0"/>
+                <a:latin typeface="Playfair Display" pitchFamily="34" charset="0"/>
                 <a:ea typeface="Arial" pitchFamily="34" charset="-122"/>
                 <a:cs typeface="Arial" pitchFamily="34" charset="-120"/>
               </a:rPr>
@@ -1892,7 +1892,7 @@
                 <a:solidFill>
                   <a:srgbClr val="151210"/>
                 </a:solidFill>
-                <a:latin typeface="Poppins" pitchFamily="34" charset="0"/>
+                <a:latin typeface="DM Sans 14pt" pitchFamily="34" charset="0"/>
                 <a:ea typeface="Arial" pitchFamily="34" charset="-122"/>
                 <a:cs typeface="Arial" pitchFamily="34" charset="-120"/>
               </a:rPr>
@@ -1931,7 +1931,7 @@
                 <a:solidFill>
                   <a:srgbClr val="96651A"/>
                 </a:solidFill>
-                <a:latin typeface="Poppins" pitchFamily="34" charset="0"/>
+                <a:latin typeface="Playfair Display" pitchFamily="34" charset="0"/>
                 <a:ea typeface="Arial" pitchFamily="34" charset="-122"/>
                 <a:cs typeface="Arial" pitchFamily="34" charset="-120"/>
               </a:rPr>
@@ -1972,7 +1972,7 @@
                 <a:solidFill>
                   <a:srgbClr val="151210"/>
                 </a:solidFill>
-                <a:latin typeface="Poppins" pitchFamily="34" charset="0"/>
+                <a:latin typeface="DM Sans 14pt" pitchFamily="34" charset="0"/>
                 <a:ea typeface="Arial" pitchFamily="34" charset="-122"/>
                 <a:cs typeface="Arial" pitchFamily="34" charset="-120"/>
               </a:rPr>
@@ -2007,70 +2007,70 @@
               <a:buNone/>
             </a:pPr>
             <a:r>
-              <a:rPr lang="en-US" sz="1100" b="1" dirty="0">
+              <a:rPr lang="en-US" sz="1100" b="1" dirty="0" spc="60">
                 <a:solidFill>
                   <a:srgbClr val="5F574E"/>
                 </a:solidFill>
-                <a:latin typeface="Poppins" pitchFamily="34" charset="0"/>
-                <a:ea typeface="Arial" pitchFamily="34" charset="-122"/>
-                <a:cs typeface="Arial" pitchFamily="34" charset="-120"/>
-              </a:rPr>
-              <a:t>MAN MOTORS S.A.  •  </a:t>
-            </a:r>
-            <a:r>
-              <a:rPr lang="en-US" sz="1100" b="1" dirty="0" err="1">
+                <a:latin typeface="DM Sans 14pt" pitchFamily="34" charset="0"/>
+                <a:ea typeface="Arial" pitchFamily="34" charset="-122"/>
+                <a:cs typeface="Arial" pitchFamily="34" charset="-120"/>
+              </a:rPr>
+              <a:t>VENDAS DE ALTA PERFORMANCE  •  O CÓDIGO DAS VENDAS INFALÍVEIS</a:t>
+            </a:r>
+            <a:r>
+              <a:rPr lang="en-US" sz="1100" b="1" dirty="0" err="1" spc="60">
                 <a:solidFill>
                   <a:srgbClr val="5F574E"/>
                 </a:solidFill>
-                <a:latin typeface="Poppins" pitchFamily="34" charset="0"/>
-                <a:ea typeface="Arial" pitchFamily="34" charset="-122"/>
-                <a:cs typeface="Arial" pitchFamily="34" charset="-120"/>
-              </a:rPr>
-              <a:t>Fuerza</a:t>
-            </a:r>
-            <a:r>
-              <a:rPr lang="en-US" sz="1100" b="1" dirty="0">
+                <a:latin typeface="DM Sans 14pt" pitchFamily="34" charset="0"/>
+                <a:ea typeface="Arial" pitchFamily="34" charset="-122"/>
+                <a:cs typeface="Arial" pitchFamily="34" charset="-120"/>
+              </a:rPr>
+              <a:t/>
+            </a:r>
+            <a:r>
+              <a:rPr lang="en-US" sz="1100" b="1" dirty="0" spc="60">
                 <a:solidFill>
                   <a:srgbClr val="5F574E"/>
                 </a:solidFill>
-                <a:latin typeface="Poppins" pitchFamily="34" charset="0"/>
-                <a:ea typeface="Arial" pitchFamily="34" charset="-122"/>
-                <a:cs typeface="Arial" pitchFamily="34" charset="-120"/>
-              </a:rPr>
-              <a:t> que </a:t>
-            </a:r>
-            <a:r>
-              <a:rPr lang="en-US" sz="1100" b="1" dirty="0" err="1">
+                <a:latin typeface="DM Sans 14pt" pitchFamily="34" charset="0"/>
+                <a:ea typeface="Arial" pitchFamily="34" charset="-122"/>
+                <a:cs typeface="Arial" pitchFamily="34" charset="-120"/>
+              </a:rPr>
+              <a:t/>
+            </a:r>
+            <a:r>
+              <a:rPr lang="en-US" sz="1100" b="1" dirty="0" err="1" spc="60">
                 <a:solidFill>
                   <a:srgbClr val="5F574E"/>
                 </a:solidFill>
-                <a:latin typeface="Poppins" pitchFamily="34" charset="0"/>
-                <a:ea typeface="Arial" pitchFamily="34" charset="-122"/>
-                <a:cs typeface="Arial" pitchFamily="34" charset="-120"/>
-              </a:rPr>
-              <a:t>conecta</a:t>
-            </a:r>
-            <a:r>
-              <a:rPr lang="en-US" sz="1100" b="1" dirty="0">
+                <a:latin typeface="DM Sans 14pt" pitchFamily="34" charset="0"/>
+                <a:ea typeface="Arial" pitchFamily="34" charset="-122"/>
+                <a:cs typeface="Arial" pitchFamily="34" charset="-120"/>
+              </a:rPr>
+              <a:t/>
+            </a:r>
+            <a:r>
+              <a:rPr lang="en-US" sz="1100" b="1" dirty="0" spc="60">
                 <a:solidFill>
                   <a:srgbClr val="5F574E"/>
                 </a:solidFill>
-                <a:latin typeface="Poppins" pitchFamily="34" charset="0"/>
-                <a:ea typeface="Arial" pitchFamily="34" charset="-122"/>
-                <a:cs typeface="Arial" pitchFamily="34" charset="-120"/>
-              </a:rPr>
-              <a:t> </a:t>
-            </a:r>
-            <a:r>
-              <a:rPr lang="en-US" sz="1100" b="1" dirty="0" err="1">
+                <a:latin typeface="DM Sans 14pt" pitchFamily="34" charset="0"/>
+                <a:ea typeface="Arial" pitchFamily="34" charset="-122"/>
+                <a:cs typeface="Arial" pitchFamily="34" charset="-120"/>
+              </a:rPr>
+              <a:t/>
+            </a:r>
+            <a:r>
+              <a:rPr lang="en-US" sz="1100" b="1" dirty="0" err="1" spc="60">
                 <a:solidFill>
                   <a:srgbClr val="5F574E"/>
                 </a:solidFill>
-                <a:latin typeface="Poppins" pitchFamily="34" charset="0"/>
-                <a:ea typeface="Arial" pitchFamily="34" charset="-122"/>
-                <a:cs typeface="Arial" pitchFamily="34" charset="-120"/>
-              </a:rPr>
-              <a:t>caminos</a:t>
+                <a:latin typeface="DM Sans 14pt" pitchFamily="34" charset="0"/>
+                <a:ea typeface="Arial" pitchFamily="34" charset="-122"/>
+                <a:cs typeface="Arial" pitchFamily="34" charset="-120"/>
+              </a:rPr>
+              <a:t/>
             </a:r>
             <a:endParaRPr lang="en-US" sz="1100" dirty="0"/>
           </a:p>
@@ -2227,7 +2227,7 @@
                 <a:solidFill>
                   <a:srgbClr val="FFFFFF"/>
                 </a:solidFill>
-                <a:latin typeface="Poppins" pitchFamily="34" charset="0"/>
+                <a:latin typeface="Playfair Display" pitchFamily="34" charset="0"/>
                 <a:ea typeface="Arial" pitchFamily="34" charset="-122"/>
                 <a:cs typeface="Arial" pitchFamily="34" charset="-120"/>
               </a:rPr>
@@ -2266,7 +2266,7 @@
                 <a:solidFill>
                   <a:srgbClr val="FFFFFF"/>
                 </a:solidFill>
-                <a:latin typeface="Poppins" pitchFamily="34" charset="0"/>
+                <a:latin typeface="DM Sans 14pt" pitchFamily="34" charset="0"/>
                 <a:ea typeface="Arial" pitchFamily="34" charset="-122"/>
                 <a:cs typeface="Arial" pitchFamily="34" charset="-120"/>
               </a:rPr>
@@ -2301,70 +2301,70 @@
               <a:buNone/>
             </a:pPr>
             <a:r>
-              <a:rPr lang="en-US" sz="850" b="1" dirty="0">
+              <a:rPr lang="en-US" sz="850" b="1" dirty="0" spc="60">
                 <a:solidFill>
                   <a:srgbClr val="FFFFFF"/>
                 </a:solidFill>
-                <a:latin typeface="Poppins" pitchFamily="34" charset="0"/>
-                <a:ea typeface="Arial" pitchFamily="34" charset="-122"/>
-                <a:cs typeface="Arial" pitchFamily="34" charset="-120"/>
-              </a:rPr>
-              <a:t>MAN MOTORS S.A.  •  </a:t>
-            </a:r>
-            <a:r>
-              <a:rPr lang="en-US" sz="850" b="1" dirty="0" err="1">
+                <a:latin typeface="DM Sans 14pt" pitchFamily="34" charset="0"/>
+                <a:ea typeface="Arial" pitchFamily="34" charset="-122"/>
+                <a:cs typeface="Arial" pitchFamily="34" charset="-120"/>
+              </a:rPr>
+              <a:t>VENDAS DE ALTA PERFORMANCE  •  O CÓDIGO DAS VENDAS INFALÍVEIS</a:t>
+            </a:r>
+            <a:r>
+              <a:rPr lang="en-US" sz="850" b="1" dirty="0" err="1" spc="60">
                 <a:solidFill>
                   <a:srgbClr val="FFFFFF"/>
                 </a:solidFill>
-                <a:latin typeface="Poppins" pitchFamily="34" charset="0"/>
-                <a:ea typeface="Arial" pitchFamily="34" charset="-122"/>
-                <a:cs typeface="Arial" pitchFamily="34" charset="-120"/>
-              </a:rPr>
-              <a:t>Fuerza</a:t>
-            </a:r>
-            <a:r>
-              <a:rPr lang="en-US" sz="850" b="1" dirty="0">
+                <a:latin typeface="DM Sans 14pt" pitchFamily="34" charset="0"/>
+                <a:ea typeface="Arial" pitchFamily="34" charset="-122"/>
+                <a:cs typeface="Arial" pitchFamily="34" charset="-120"/>
+              </a:rPr>
+              <a:t/>
+            </a:r>
+            <a:r>
+              <a:rPr lang="en-US" sz="850" b="1" dirty="0" spc="60">
                 <a:solidFill>
                   <a:srgbClr val="FFFFFF"/>
                 </a:solidFill>
-                <a:latin typeface="Poppins" pitchFamily="34" charset="0"/>
-                <a:ea typeface="Arial" pitchFamily="34" charset="-122"/>
-                <a:cs typeface="Arial" pitchFamily="34" charset="-120"/>
-              </a:rPr>
-              <a:t> que </a:t>
-            </a:r>
-            <a:r>
-              <a:rPr lang="en-US" sz="850" b="1" dirty="0" err="1">
+                <a:latin typeface="DM Sans 14pt" pitchFamily="34" charset="0"/>
+                <a:ea typeface="Arial" pitchFamily="34" charset="-122"/>
+                <a:cs typeface="Arial" pitchFamily="34" charset="-120"/>
+              </a:rPr>
+              <a:t/>
+            </a:r>
+            <a:r>
+              <a:rPr lang="en-US" sz="850" b="1" dirty="0" err="1" spc="60">
                 <a:solidFill>
                   <a:srgbClr val="FFFFFF"/>
                 </a:solidFill>
-                <a:latin typeface="Poppins" pitchFamily="34" charset="0"/>
-                <a:ea typeface="Arial" pitchFamily="34" charset="-122"/>
-                <a:cs typeface="Arial" pitchFamily="34" charset="-120"/>
-              </a:rPr>
-              <a:t>conecta</a:t>
-            </a:r>
-            <a:r>
-              <a:rPr lang="en-US" sz="850" b="1" dirty="0">
+                <a:latin typeface="DM Sans 14pt" pitchFamily="34" charset="0"/>
+                <a:ea typeface="Arial" pitchFamily="34" charset="-122"/>
+                <a:cs typeface="Arial" pitchFamily="34" charset="-120"/>
+              </a:rPr>
+              <a:t/>
+            </a:r>
+            <a:r>
+              <a:rPr lang="en-US" sz="850" b="1" dirty="0" spc="60">
                 <a:solidFill>
                   <a:srgbClr val="FFFFFF"/>
                 </a:solidFill>
-                <a:latin typeface="Poppins" pitchFamily="34" charset="0"/>
-                <a:ea typeface="Arial" pitchFamily="34" charset="-122"/>
-                <a:cs typeface="Arial" pitchFamily="34" charset="-120"/>
-              </a:rPr>
-              <a:t> </a:t>
-            </a:r>
-            <a:r>
-              <a:rPr lang="en-US" sz="850" b="1" dirty="0" err="1">
+                <a:latin typeface="DM Sans 14pt" pitchFamily="34" charset="0"/>
+                <a:ea typeface="Arial" pitchFamily="34" charset="-122"/>
+                <a:cs typeface="Arial" pitchFamily="34" charset="-120"/>
+              </a:rPr>
+              <a:t/>
+            </a:r>
+            <a:r>
+              <a:rPr lang="en-US" sz="850" b="1" dirty="0" err="1" spc="60">
                 <a:solidFill>
                   <a:srgbClr val="FFFFFF"/>
                 </a:solidFill>
-                <a:latin typeface="Poppins" pitchFamily="34" charset="0"/>
-                <a:ea typeface="Arial" pitchFamily="34" charset="-122"/>
-                <a:cs typeface="Arial" pitchFamily="34" charset="-120"/>
-              </a:rPr>
-              <a:t>caminos</a:t>
+                <a:latin typeface="DM Sans 14pt" pitchFamily="34" charset="0"/>
+                <a:ea typeface="Arial" pitchFamily="34" charset="-122"/>
+                <a:cs typeface="Arial" pitchFamily="34" charset="-120"/>
+              </a:rPr>
+              <a:t/>
             </a:r>
             <a:endParaRPr lang="en-US" sz="850" dirty="0"/>
           </a:p>
@@ -2395,11 +2395,11 @@
               <a:buNone/>
             </a:pPr>
             <a:r>
-              <a:rPr lang="en-US" sz="850" dirty="0">
+              <a:rPr lang="en-US" sz="850" dirty="0" spc="60">
                 <a:solidFill>
                   <a:srgbClr val="FFFFFF"/>
                 </a:solidFill>
-                <a:latin typeface="Poppins" pitchFamily="34" charset="0"/>
+                <a:latin typeface="DM Sans 14pt" pitchFamily="34" charset="0"/>
                 <a:ea typeface="Arial" pitchFamily="34" charset="-122"/>
                 <a:cs typeface="Arial" pitchFamily="34" charset="-120"/>
               </a:rPr>
@@ -2496,7 +2496,7 @@
                 <a:solidFill>
                   <a:srgbClr val="151210"/>
                 </a:solidFill>
-                <a:latin typeface="Poppins" pitchFamily="34" charset="0"/>
+                <a:latin typeface="Playfair Display" pitchFamily="34" charset="0"/>
                 <a:ea typeface="Arial" pitchFamily="34" charset="-122"/>
                 <a:cs typeface="Arial" pitchFamily="34" charset="-120"/>
               </a:rPr>
@@ -2535,7 +2535,7 @@
                 <a:solidFill>
                   <a:srgbClr val="C08A2A"/>
                 </a:solidFill>
-                <a:latin typeface="Poppins" pitchFamily="34" charset="0"/>
+                <a:latin typeface="DM Sans 14pt" pitchFamily="34" charset="0"/>
                 <a:ea typeface="Arial" pitchFamily="34" charset="-122"/>
                 <a:cs typeface="Arial" pitchFamily="34" charset="-120"/>
               </a:rPr>
@@ -2576,7 +2576,7 @@
                 <a:solidFill>
                   <a:srgbClr val="151210"/>
                 </a:solidFill>
-                <a:latin typeface="Poppins" pitchFamily="34" charset="0"/>
+                <a:latin typeface="Playfair Display" pitchFamily="34" charset="0"/>
                 <a:ea typeface="Arial" pitchFamily="34" charset="-122"/>
                 <a:cs typeface="Arial" pitchFamily="34" charset="-120"/>
               </a:rPr>
@@ -2617,7 +2617,7 @@
                 <a:solidFill>
                   <a:srgbClr val="151210"/>
                 </a:solidFill>
-                <a:latin typeface="Poppins" pitchFamily="34" charset="0"/>
+                <a:latin typeface="DM Sans 14pt" pitchFamily="34" charset="0"/>
                 <a:ea typeface="Arial" pitchFamily="34" charset="-122"/>
                 <a:cs typeface="Arial" pitchFamily="34" charset="-120"/>
               </a:rPr>
@@ -2683,7 +2683,7 @@
                 <a:solidFill>
                   <a:srgbClr val="96651A"/>
                 </a:solidFill>
-                <a:latin typeface="Poppins" pitchFamily="34" charset="0"/>
+                <a:latin typeface="Playfair Display" pitchFamily="34" charset="0"/>
                 <a:ea typeface="Arial" pitchFamily="34" charset="-122"/>
                 <a:cs typeface="Arial" pitchFamily="34" charset="-120"/>
               </a:rPr>
@@ -2724,7 +2724,7 @@
                 <a:solidFill>
                   <a:srgbClr val="151210"/>
                 </a:solidFill>
-                <a:latin typeface="Poppins" pitchFamily="34" charset="0"/>
+                <a:latin typeface="DM Sans 14pt" pitchFamily="34" charset="0"/>
                 <a:ea typeface="Arial" pitchFamily="34" charset="-122"/>
                 <a:cs typeface="Arial" pitchFamily="34" charset="-120"/>
               </a:rPr>
@@ -2741,7 +2741,7 @@
                 <a:solidFill>
                   <a:srgbClr val="151210"/>
                 </a:solidFill>
-                <a:latin typeface="Poppins" pitchFamily="34" charset="0"/>
+                <a:latin typeface="DM Sans 14pt" pitchFamily="34" charset="0"/>
                 <a:ea typeface="Arial" pitchFamily="34" charset="-122"/>
                 <a:cs typeface="Arial" pitchFamily="34" charset="-120"/>
               </a:rPr>
@@ -2758,7 +2758,7 @@
                 <a:solidFill>
                   <a:srgbClr val="151210"/>
                 </a:solidFill>
-                <a:latin typeface="Poppins" pitchFamily="34" charset="0"/>
+                <a:latin typeface="DM Sans 14pt" pitchFamily="34" charset="0"/>
                 <a:ea typeface="Arial" pitchFamily="34" charset="-122"/>
                 <a:cs typeface="Arial" pitchFamily="34" charset="-120"/>
               </a:rPr>
@@ -2826,7 +2826,7 @@
                 <a:solidFill>
                   <a:srgbClr val="151210"/>
                 </a:solidFill>
-                <a:latin typeface="Poppins" pitchFamily="34" charset="0"/>
+                <a:latin typeface="Playfair Display" pitchFamily="34" charset="0"/>
                 <a:ea typeface="Arial" pitchFamily="34" charset="-122"/>
                 <a:cs typeface="Arial" pitchFamily="34" charset="-120"/>
               </a:rPr>
@@ -2867,7 +2867,7 @@
                 <a:solidFill>
                   <a:srgbClr val="96651A"/>
                 </a:solidFill>
-                <a:latin typeface="Poppins" pitchFamily="34" charset="0"/>
+                <a:latin typeface="Playfair Display" pitchFamily="34" charset="0"/>
                 <a:ea typeface="Arial" pitchFamily="34" charset="-122"/>
                 <a:cs typeface="Arial" pitchFamily="34" charset="-120"/>
               </a:rPr>
@@ -2931,11 +2931,11 @@
               <a:buNone/>
             </a:pPr>
             <a:r>
-              <a:rPr lang="en-US" sz="1000" b="1" dirty="0">
+              <a:rPr lang="en-US" sz="1000" b="1" dirty="0" spc="60">
                 <a:solidFill>
                   <a:srgbClr val="E6BD5E"/>
                 </a:solidFill>
-                <a:latin typeface="Poppins" pitchFamily="34" charset="0"/>
+                <a:latin typeface="DM Sans 14pt" pitchFamily="34" charset="0"/>
                 <a:ea typeface="Arial" pitchFamily="34" charset="-122"/>
                 <a:cs typeface="Arial" pitchFamily="34" charset="-120"/>
               </a:rPr>
@@ -2976,7 +2976,7 @@
                 <a:solidFill>
                   <a:srgbClr val="FFFFFF"/>
                 </a:solidFill>
-                <a:latin typeface="Poppins" pitchFamily="34" charset="0"/>
+                <a:latin typeface="DM Sans 14pt" pitchFamily="34" charset="0"/>
                 <a:ea typeface="Arial" pitchFamily="34" charset="-122"/>
                 <a:cs typeface="Arial" pitchFamily="34" charset="-120"/>
               </a:rPr>
@@ -3137,7 +3137,7 @@
                 <a:solidFill>
                   <a:srgbClr val="FFFFFF"/>
                 </a:solidFill>
-                <a:latin typeface="Poppins" pitchFamily="34" charset="0"/>
+                <a:latin typeface="Playfair Display" pitchFamily="34" charset="0"/>
                 <a:ea typeface="Arial" pitchFamily="34" charset="-122"/>
                 <a:cs typeface="Arial" pitchFamily="34" charset="-120"/>
               </a:rPr>
@@ -3176,7 +3176,7 @@
                 <a:solidFill>
                   <a:srgbClr val="FFFFFF"/>
                 </a:solidFill>
-                <a:latin typeface="Poppins" pitchFamily="34" charset="0"/>
+                <a:latin typeface="DM Sans 14pt" pitchFamily="34" charset="0"/>
                 <a:ea typeface="Arial" pitchFamily="34" charset="-122"/>
                 <a:cs typeface="Arial" pitchFamily="34" charset="-120"/>
               </a:rPr>
@@ -3211,70 +3211,70 @@
               <a:buNone/>
             </a:pPr>
             <a:r>
-              <a:rPr lang="en-US" sz="850" b="1" dirty="0">
+              <a:rPr lang="en-US" sz="850" b="1" dirty="0" spc="60">
                 <a:solidFill>
                   <a:srgbClr val="FFFFFF"/>
                 </a:solidFill>
-                <a:latin typeface="Poppins" pitchFamily="34" charset="0"/>
-                <a:ea typeface="Arial" pitchFamily="34" charset="-122"/>
-                <a:cs typeface="Arial" pitchFamily="34" charset="-120"/>
-              </a:rPr>
-              <a:t>MAN MOTORS S.A.  •  </a:t>
-            </a:r>
-            <a:r>
-              <a:rPr lang="en-US" sz="850" b="1" dirty="0" err="1">
+                <a:latin typeface="DM Sans 14pt" pitchFamily="34" charset="0"/>
+                <a:ea typeface="Arial" pitchFamily="34" charset="-122"/>
+                <a:cs typeface="Arial" pitchFamily="34" charset="-120"/>
+              </a:rPr>
+              <a:t>VENDAS DE ALTA PERFORMANCE  •  O CÓDIGO DAS VENDAS INFALÍVEIS</a:t>
+            </a:r>
+            <a:r>
+              <a:rPr lang="en-US" sz="850" b="1" dirty="0" err="1" spc="60">
                 <a:solidFill>
                   <a:srgbClr val="FFFFFF"/>
                 </a:solidFill>
-                <a:latin typeface="Poppins" pitchFamily="34" charset="0"/>
-                <a:ea typeface="Arial" pitchFamily="34" charset="-122"/>
-                <a:cs typeface="Arial" pitchFamily="34" charset="-120"/>
-              </a:rPr>
-              <a:t>Fuerza</a:t>
-            </a:r>
-            <a:r>
-              <a:rPr lang="en-US" sz="850" b="1" dirty="0">
+                <a:latin typeface="DM Sans 14pt" pitchFamily="34" charset="0"/>
+                <a:ea typeface="Arial" pitchFamily="34" charset="-122"/>
+                <a:cs typeface="Arial" pitchFamily="34" charset="-120"/>
+              </a:rPr>
+              <a:t/>
+            </a:r>
+            <a:r>
+              <a:rPr lang="en-US" sz="850" b="1" dirty="0" spc="60">
                 <a:solidFill>
                   <a:srgbClr val="FFFFFF"/>
                 </a:solidFill>
-                <a:latin typeface="Poppins" pitchFamily="34" charset="0"/>
-                <a:ea typeface="Arial" pitchFamily="34" charset="-122"/>
-                <a:cs typeface="Arial" pitchFamily="34" charset="-120"/>
-              </a:rPr>
-              <a:t> que </a:t>
-            </a:r>
-            <a:r>
-              <a:rPr lang="en-US" sz="850" b="1" dirty="0" err="1">
+                <a:latin typeface="DM Sans 14pt" pitchFamily="34" charset="0"/>
+                <a:ea typeface="Arial" pitchFamily="34" charset="-122"/>
+                <a:cs typeface="Arial" pitchFamily="34" charset="-120"/>
+              </a:rPr>
+              <a:t/>
+            </a:r>
+            <a:r>
+              <a:rPr lang="en-US" sz="850" b="1" dirty="0" err="1" spc="60">
                 <a:solidFill>
                   <a:srgbClr val="FFFFFF"/>
                 </a:solidFill>
-                <a:latin typeface="Poppins" pitchFamily="34" charset="0"/>
-                <a:ea typeface="Arial" pitchFamily="34" charset="-122"/>
-                <a:cs typeface="Arial" pitchFamily="34" charset="-120"/>
-              </a:rPr>
-              <a:t>conecta</a:t>
-            </a:r>
-            <a:r>
-              <a:rPr lang="en-US" sz="850" b="1" dirty="0">
+                <a:latin typeface="DM Sans 14pt" pitchFamily="34" charset="0"/>
+                <a:ea typeface="Arial" pitchFamily="34" charset="-122"/>
+                <a:cs typeface="Arial" pitchFamily="34" charset="-120"/>
+              </a:rPr>
+              <a:t/>
+            </a:r>
+            <a:r>
+              <a:rPr lang="en-US" sz="850" b="1" dirty="0" spc="60">
                 <a:solidFill>
                   <a:srgbClr val="FFFFFF"/>
                 </a:solidFill>
-                <a:latin typeface="Poppins" pitchFamily="34" charset="0"/>
-                <a:ea typeface="Arial" pitchFamily="34" charset="-122"/>
-                <a:cs typeface="Arial" pitchFamily="34" charset="-120"/>
-              </a:rPr>
-              <a:t> </a:t>
-            </a:r>
-            <a:r>
-              <a:rPr lang="en-US" sz="850" b="1" dirty="0" err="1">
+                <a:latin typeface="DM Sans 14pt" pitchFamily="34" charset="0"/>
+                <a:ea typeface="Arial" pitchFamily="34" charset="-122"/>
+                <a:cs typeface="Arial" pitchFamily="34" charset="-120"/>
+              </a:rPr>
+              <a:t/>
+            </a:r>
+            <a:r>
+              <a:rPr lang="en-US" sz="850" b="1" dirty="0" err="1" spc="60">
                 <a:solidFill>
                   <a:srgbClr val="FFFFFF"/>
                 </a:solidFill>
-                <a:latin typeface="Poppins" pitchFamily="34" charset="0"/>
-                <a:ea typeface="Arial" pitchFamily="34" charset="-122"/>
-                <a:cs typeface="Arial" pitchFamily="34" charset="-120"/>
-              </a:rPr>
-              <a:t>caminos</a:t>
+                <a:latin typeface="DM Sans 14pt" pitchFamily="34" charset="0"/>
+                <a:ea typeface="Arial" pitchFamily="34" charset="-122"/>
+                <a:cs typeface="Arial" pitchFamily="34" charset="-120"/>
+              </a:rPr>
+              <a:t/>
             </a:r>
             <a:endParaRPr lang="en-US" sz="850" dirty="0"/>
           </a:p>
@@ -3305,11 +3305,11 @@
               <a:buNone/>
             </a:pPr>
             <a:r>
-              <a:rPr lang="en-US" sz="850" dirty="0">
+              <a:rPr lang="en-US" sz="850" dirty="0" spc="60">
                 <a:solidFill>
                   <a:srgbClr val="FFFFFF"/>
                 </a:solidFill>
-                <a:latin typeface="Poppins" pitchFamily="34" charset="0"/>
+                <a:latin typeface="DM Sans 14pt" pitchFamily="34" charset="0"/>
                 <a:ea typeface="Arial" pitchFamily="34" charset="-122"/>
                 <a:cs typeface="Arial" pitchFamily="34" charset="-120"/>
               </a:rPr>
@@ -3406,7 +3406,7 @@
                 <a:solidFill>
                   <a:srgbClr val="151210"/>
                 </a:solidFill>
-                <a:latin typeface="Poppins" pitchFamily="34" charset="0"/>
+                <a:latin typeface="Playfair Display" pitchFamily="34" charset="0"/>
                 <a:ea typeface="Arial" pitchFamily="34" charset="-122"/>
                 <a:cs typeface="Arial" pitchFamily="34" charset="-120"/>
               </a:rPr>
@@ -3445,7 +3445,7 @@
                 <a:solidFill>
                   <a:srgbClr val="C08A2A"/>
                 </a:solidFill>
-                <a:latin typeface="Poppins" pitchFamily="34" charset="0"/>
+                <a:latin typeface="DM Sans 14pt" pitchFamily="34" charset="0"/>
                 <a:ea typeface="Arial" pitchFamily="34" charset="-122"/>
                 <a:cs typeface="Arial" pitchFamily="34" charset="-120"/>
               </a:rPr>
@@ -3486,7 +3486,7 @@
                 <a:solidFill>
                   <a:srgbClr val="151210"/>
                 </a:solidFill>
-                <a:latin typeface="Poppins" pitchFamily="34" charset="0"/>
+                <a:latin typeface="Playfair Display" pitchFamily="34" charset="0"/>
                 <a:ea typeface="Arial" pitchFamily="34" charset="-122"/>
                 <a:cs typeface="Arial" pitchFamily="34" charset="-120"/>
               </a:rPr>
@@ -3527,7 +3527,7 @@
                 <a:solidFill>
                   <a:srgbClr val="151210"/>
                 </a:solidFill>
-                <a:latin typeface="Poppins" pitchFamily="34" charset="0"/>
+                <a:latin typeface="DM Sans 14pt" pitchFamily="34" charset="0"/>
                 <a:ea typeface="Arial" pitchFamily="34" charset="-122"/>
                 <a:cs typeface="Arial" pitchFamily="34" charset="-120"/>
               </a:rPr>
@@ -3593,7 +3593,7 @@
                 <a:solidFill>
                   <a:srgbClr val="96651A"/>
                 </a:solidFill>
-                <a:latin typeface="Poppins" pitchFamily="34" charset="0"/>
+                <a:latin typeface="Playfair Display" pitchFamily="34" charset="0"/>
                 <a:ea typeface="Arial" pitchFamily="34" charset="-122"/>
                 <a:cs typeface="Arial" pitchFamily="34" charset="-120"/>
               </a:rPr>
@@ -3634,7 +3634,7 @@
                 <a:solidFill>
                   <a:srgbClr val="151210"/>
                 </a:solidFill>
-                <a:latin typeface="Poppins" pitchFamily="34" charset="0"/>
+                <a:latin typeface="DM Sans 14pt" pitchFamily="34" charset="0"/>
                 <a:ea typeface="Arial" pitchFamily="34" charset="-122"/>
                 <a:cs typeface="Arial" pitchFamily="34" charset="-120"/>
               </a:rPr>
@@ -3651,7 +3651,7 @@
                 <a:solidFill>
                   <a:srgbClr val="151210"/>
                 </a:solidFill>
-                <a:latin typeface="Poppins" pitchFamily="34" charset="0"/>
+                <a:latin typeface="DM Sans 14pt" pitchFamily="34" charset="0"/>
                 <a:ea typeface="Arial" pitchFamily="34" charset="-122"/>
                 <a:cs typeface="Arial" pitchFamily="34" charset="-120"/>
               </a:rPr>
@@ -3668,7 +3668,7 @@
                 <a:solidFill>
                   <a:srgbClr val="151210"/>
                 </a:solidFill>
-                <a:latin typeface="Poppins" pitchFamily="34" charset="0"/>
+                <a:latin typeface="DM Sans 14pt" pitchFamily="34" charset="0"/>
                 <a:ea typeface="Arial" pitchFamily="34" charset="-122"/>
                 <a:cs typeface="Arial" pitchFamily="34" charset="-120"/>
               </a:rPr>
@@ -3736,7 +3736,7 @@
                 <a:solidFill>
                   <a:srgbClr val="151210"/>
                 </a:solidFill>
-                <a:latin typeface="Poppins" pitchFamily="34" charset="0"/>
+                <a:latin typeface="Playfair Display" pitchFamily="34" charset="0"/>
                 <a:ea typeface="Arial" pitchFamily="34" charset="-122"/>
                 <a:cs typeface="Arial" pitchFamily="34" charset="-120"/>
               </a:rPr>
@@ -3777,7 +3777,7 @@
                 <a:solidFill>
                   <a:srgbClr val="96651A"/>
                 </a:solidFill>
-                <a:latin typeface="Poppins" pitchFamily="34" charset="0"/>
+                <a:latin typeface="Playfair Display" pitchFamily="34" charset="0"/>
                 <a:ea typeface="Arial" pitchFamily="34" charset="-122"/>
                 <a:cs typeface="Arial" pitchFamily="34" charset="-120"/>
               </a:rPr>
@@ -3841,11 +3841,11 @@
               <a:buNone/>
             </a:pPr>
             <a:r>
-              <a:rPr lang="en-US" sz="1000" b="1" dirty="0">
+              <a:rPr lang="en-US" sz="1000" b="1" dirty="0" spc="60">
                 <a:solidFill>
                   <a:srgbClr val="E6BD5E"/>
                 </a:solidFill>
-                <a:latin typeface="Poppins" pitchFamily="34" charset="0"/>
+                <a:latin typeface="DM Sans 14pt" pitchFamily="34" charset="0"/>
                 <a:ea typeface="Arial" pitchFamily="34" charset="-122"/>
                 <a:cs typeface="Arial" pitchFamily="34" charset="-120"/>
               </a:rPr>
@@ -3886,7 +3886,7 @@
                 <a:solidFill>
                   <a:srgbClr val="FFFFFF"/>
                 </a:solidFill>
-                <a:latin typeface="Poppins" pitchFamily="34" charset="0"/>
+                <a:latin typeface="DM Sans 14pt" pitchFamily="34" charset="0"/>
                 <a:ea typeface="Arial" pitchFamily="34" charset="-122"/>
                 <a:cs typeface="Arial" pitchFamily="34" charset="-120"/>
               </a:rPr>
@@ -4047,7 +4047,7 @@
                 <a:solidFill>
                   <a:srgbClr val="FFFFFF"/>
                 </a:solidFill>
-                <a:latin typeface="Poppins" pitchFamily="34" charset="0"/>
+                <a:latin typeface="Playfair Display" pitchFamily="34" charset="0"/>
                 <a:ea typeface="Arial" pitchFamily="34" charset="-122"/>
                 <a:cs typeface="Arial" pitchFamily="34" charset="-120"/>
               </a:rPr>
@@ -4086,7 +4086,7 @@
                 <a:solidFill>
                   <a:srgbClr val="FFFFFF"/>
                 </a:solidFill>
-                <a:latin typeface="Poppins" pitchFamily="34" charset="0"/>
+                <a:latin typeface="DM Sans 14pt" pitchFamily="34" charset="0"/>
                 <a:ea typeface="Arial" pitchFamily="34" charset="-122"/>
                 <a:cs typeface="Arial" pitchFamily="34" charset="-120"/>
               </a:rPr>
@@ -4121,70 +4121,70 @@
               <a:buNone/>
             </a:pPr>
             <a:r>
-              <a:rPr lang="en-US" sz="850" b="1" dirty="0">
+              <a:rPr lang="en-US" sz="850" b="1" dirty="0" spc="60">
                 <a:solidFill>
                   <a:srgbClr val="FFFFFF"/>
                 </a:solidFill>
-                <a:latin typeface="Poppins" pitchFamily="34" charset="0"/>
-                <a:ea typeface="Arial" pitchFamily="34" charset="-122"/>
-                <a:cs typeface="Arial" pitchFamily="34" charset="-120"/>
-              </a:rPr>
-              <a:t>MAN MOTORS S.A.  •  </a:t>
-            </a:r>
-            <a:r>
-              <a:rPr lang="en-US" sz="850" b="1" dirty="0" err="1">
+                <a:latin typeface="DM Sans 14pt" pitchFamily="34" charset="0"/>
+                <a:ea typeface="Arial" pitchFamily="34" charset="-122"/>
+                <a:cs typeface="Arial" pitchFamily="34" charset="-120"/>
+              </a:rPr>
+              <a:t>VENDAS DE ALTA PERFORMANCE  •  O CÓDIGO DAS VENDAS INFALÍVEIS</a:t>
+            </a:r>
+            <a:r>
+              <a:rPr lang="en-US" sz="850" b="1" dirty="0" err="1" spc="60">
                 <a:solidFill>
                   <a:srgbClr val="FFFFFF"/>
                 </a:solidFill>
-                <a:latin typeface="Poppins" pitchFamily="34" charset="0"/>
-                <a:ea typeface="Arial" pitchFamily="34" charset="-122"/>
-                <a:cs typeface="Arial" pitchFamily="34" charset="-120"/>
-              </a:rPr>
-              <a:t>Fuerza</a:t>
-            </a:r>
-            <a:r>
-              <a:rPr lang="en-US" sz="850" b="1" dirty="0">
+                <a:latin typeface="DM Sans 14pt" pitchFamily="34" charset="0"/>
+                <a:ea typeface="Arial" pitchFamily="34" charset="-122"/>
+                <a:cs typeface="Arial" pitchFamily="34" charset="-120"/>
+              </a:rPr>
+              <a:t/>
+            </a:r>
+            <a:r>
+              <a:rPr lang="en-US" sz="850" b="1" dirty="0" spc="60">
                 <a:solidFill>
                   <a:srgbClr val="FFFFFF"/>
                 </a:solidFill>
-                <a:latin typeface="Poppins" pitchFamily="34" charset="0"/>
-                <a:ea typeface="Arial" pitchFamily="34" charset="-122"/>
-                <a:cs typeface="Arial" pitchFamily="34" charset="-120"/>
-              </a:rPr>
-              <a:t> que </a:t>
-            </a:r>
-            <a:r>
-              <a:rPr lang="en-US" sz="850" b="1" dirty="0" err="1">
+                <a:latin typeface="DM Sans 14pt" pitchFamily="34" charset="0"/>
+                <a:ea typeface="Arial" pitchFamily="34" charset="-122"/>
+                <a:cs typeface="Arial" pitchFamily="34" charset="-120"/>
+              </a:rPr>
+              <a:t/>
+            </a:r>
+            <a:r>
+              <a:rPr lang="en-US" sz="850" b="1" dirty="0" err="1" spc="60">
                 <a:solidFill>
                   <a:srgbClr val="FFFFFF"/>
                 </a:solidFill>
-                <a:latin typeface="Poppins" pitchFamily="34" charset="0"/>
-                <a:ea typeface="Arial" pitchFamily="34" charset="-122"/>
-                <a:cs typeface="Arial" pitchFamily="34" charset="-120"/>
-              </a:rPr>
-              <a:t>conecta</a:t>
-            </a:r>
-            <a:r>
-              <a:rPr lang="en-US" sz="850" b="1" dirty="0">
+                <a:latin typeface="DM Sans 14pt" pitchFamily="34" charset="0"/>
+                <a:ea typeface="Arial" pitchFamily="34" charset="-122"/>
+                <a:cs typeface="Arial" pitchFamily="34" charset="-120"/>
+              </a:rPr>
+              <a:t/>
+            </a:r>
+            <a:r>
+              <a:rPr lang="en-US" sz="850" b="1" dirty="0" spc="60">
                 <a:solidFill>
                   <a:srgbClr val="FFFFFF"/>
                 </a:solidFill>
-                <a:latin typeface="Poppins" pitchFamily="34" charset="0"/>
-                <a:ea typeface="Arial" pitchFamily="34" charset="-122"/>
-                <a:cs typeface="Arial" pitchFamily="34" charset="-120"/>
-              </a:rPr>
-              <a:t> </a:t>
-            </a:r>
-            <a:r>
-              <a:rPr lang="en-US" sz="850" b="1" dirty="0" err="1">
+                <a:latin typeface="DM Sans 14pt" pitchFamily="34" charset="0"/>
+                <a:ea typeface="Arial" pitchFamily="34" charset="-122"/>
+                <a:cs typeface="Arial" pitchFamily="34" charset="-120"/>
+              </a:rPr>
+              <a:t/>
+            </a:r>
+            <a:r>
+              <a:rPr lang="en-US" sz="850" b="1" dirty="0" err="1" spc="60">
                 <a:solidFill>
                   <a:srgbClr val="FFFFFF"/>
                 </a:solidFill>
-                <a:latin typeface="Poppins" pitchFamily="34" charset="0"/>
-                <a:ea typeface="Arial" pitchFamily="34" charset="-122"/>
-                <a:cs typeface="Arial" pitchFamily="34" charset="-120"/>
-              </a:rPr>
-              <a:t>caminos</a:t>
+                <a:latin typeface="DM Sans 14pt" pitchFamily="34" charset="0"/>
+                <a:ea typeface="Arial" pitchFamily="34" charset="-122"/>
+                <a:cs typeface="Arial" pitchFamily="34" charset="-120"/>
+              </a:rPr>
+              <a:t/>
             </a:r>
             <a:endParaRPr lang="en-US" sz="850" dirty="0"/>
           </a:p>
@@ -4215,11 +4215,11 @@
               <a:buNone/>
             </a:pPr>
             <a:r>
-              <a:rPr lang="en-US" sz="850" dirty="0">
+              <a:rPr lang="en-US" sz="850" dirty="0" spc="60">
                 <a:solidFill>
                   <a:srgbClr val="FFFFFF"/>
                 </a:solidFill>
-                <a:latin typeface="Poppins" pitchFamily="34" charset="0"/>
+                <a:latin typeface="DM Sans 14pt" pitchFamily="34" charset="0"/>
                 <a:ea typeface="Arial" pitchFamily="34" charset="-122"/>
                 <a:cs typeface="Arial" pitchFamily="34" charset="-120"/>
               </a:rPr>
@@ -4289,7 +4289,7 @@
                 <a:solidFill>
                   <a:srgbClr val="151210"/>
                 </a:solidFill>
-                <a:latin typeface="Poppins" pitchFamily="34" charset="0"/>
+                <a:latin typeface="Playfair Display" pitchFamily="34" charset="0"/>
                 <a:ea typeface="Arial" pitchFamily="34" charset="-122"/>
                 <a:cs typeface="Arial" pitchFamily="34" charset="-120"/>
               </a:rPr>
@@ -4357,7 +4357,7 @@
                 <a:solidFill>
                   <a:srgbClr val="96651A"/>
                 </a:solidFill>
-                <a:latin typeface="Poppins" pitchFamily="34" charset="0"/>
+                <a:latin typeface="Playfair Display" pitchFamily="34" charset="0"/>
                 <a:ea typeface="Arial" pitchFamily="34" charset="-122"/>
                 <a:cs typeface="Arial" pitchFamily="34" charset="-120"/>
               </a:rPr>
@@ -4398,7 +4398,7 @@
                 <a:solidFill>
                   <a:srgbClr val="151210"/>
                 </a:solidFill>
-                <a:latin typeface="Poppins" pitchFamily="34" charset="0"/>
+                <a:latin typeface="DM Sans 14pt" pitchFamily="34" charset="0"/>
                 <a:ea typeface="Arial" pitchFamily="34" charset="-122"/>
                 <a:cs typeface="Arial" pitchFamily="34" charset="-120"/>
               </a:rPr>
@@ -4415,7 +4415,7 @@
                 <a:solidFill>
                   <a:srgbClr val="151210"/>
                 </a:solidFill>
-                <a:latin typeface="Poppins" pitchFamily="34" charset="0"/>
+                <a:latin typeface="DM Sans 14pt" pitchFamily="34" charset="0"/>
                 <a:ea typeface="Arial" pitchFamily="34" charset="-122"/>
                 <a:cs typeface="Arial" pitchFamily="34" charset="-120"/>
               </a:rPr>
@@ -4432,7 +4432,7 @@
                 <a:solidFill>
                   <a:srgbClr val="151210"/>
                 </a:solidFill>
-                <a:latin typeface="Poppins" pitchFamily="34" charset="0"/>
+                <a:latin typeface="DM Sans 14pt" pitchFamily="34" charset="0"/>
                 <a:ea typeface="Arial" pitchFamily="34" charset="-122"/>
                 <a:cs typeface="Arial" pitchFamily="34" charset="-120"/>
               </a:rPr>
@@ -4449,7 +4449,7 @@
                 <a:solidFill>
                   <a:srgbClr val="151210"/>
                 </a:solidFill>
-                <a:latin typeface="Poppins" pitchFamily="34" charset="0"/>
+                <a:latin typeface="DM Sans 14pt" pitchFamily="34" charset="0"/>
                 <a:ea typeface="Arial" pitchFamily="34" charset="-122"/>
                 <a:cs typeface="Arial" pitchFamily="34" charset="-120"/>
               </a:rPr>
@@ -4466,7 +4466,7 @@
                 <a:solidFill>
                   <a:srgbClr val="151210"/>
                 </a:solidFill>
-                <a:latin typeface="Poppins" pitchFamily="34" charset="0"/>
+                <a:latin typeface="DM Sans 14pt" pitchFamily="34" charset="0"/>
                 <a:ea typeface="Arial" pitchFamily="34" charset="-122"/>
                 <a:cs typeface="Arial" pitchFamily="34" charset="-120"/>
               </a:rPr>
@@ -4483,7 +4483,7 @@
                 <a:solidFill>
                   <a:srgbClr val="151210"/>
                 </a:solidFill>
-                <a:latin typeface="Poppins" pitchFamily="34" charset="0"/>
+                <a:latin typeface="DM Sans 14pt" pitchFamily="34" charset="0"/>
                 <a:ea typeface="Arial" pitchFamily="34" charset="-122"/>
                 <a:cs typeface="Arial" pitchFamily="34" charset="-120"/>
               </a:rPr>
@@ -4500,7 +4500,7 @@
                 <a:solidFill>
                   <a:srgbClr val="151210"/>
                 </a:solidFill>
-                <a:latin typeface="Poppins" pitchFamily="34" charset="0"/>
+                <a:latin typeface="DM Sans 14pt" pitchFamily="34" charset="0"/>
                 <a:ea typeface="Arial" pitchFamily="34" charset="-122"/>
                 <a:cs typeface="Arial" pitchFamily="34" charset="-120"/>
               </a:rPr>
@@ -4517,7 +4517,7 @@
                 <a:solidFill>
                   <a:srgbClr val="151210"/>
                 </a:solidFill>
-                <a:latin typeface="Poppins" pitchFamily="34" charset="0"/>
+                <a:latin typeface="DM Sans 14pt" pitchFamily="34" charset="0"/>
                 <a:ea typeface="Arial" pitchFamily="34" charset="-122"/>
                 <a:cs typeface="Arial" pitchFamily="34" charset="-120"/>
               </a:rPr>
@@ -4534,7 +4534,7 @@
                 <a:solidFill>
                   <a:srgbClr val="151210"/>
                 </a:solidFill>
-                <a:latin typeface="Poppins" pitchFamily="34" charset="0"/>
+                <a:latin typeface="DM Sans 14pt" pitchFamily="34" charset="0"/>
                 <a:ea typeface="Arial" pitchFamily="34" charset="-122"/>
                 <a:cs typeface="Arial" pitchFamily="34" charset="-120"/>
               </a:rPr>
@@ -4602,7 +4602,7 @@
                 <a:solidFill>
                   <a:srgbClr val="96651A"/>
                 </a:solidFill>
-                <a:latin typeface="Poppins" pitchFamily="34" charset="0"/>
+                <a:latin typeface="Playfair Display" pitchFamily="34" charset="0"/>
                 <a:ea typeface="Arial" pitchFamily="34" charset="-122"/>
                 <a:cs typeface="Arial" pitchFamily="34" charset="-120"/>
               </a:rPr>
@@ -4641,7 +4641,7 @@
                 <a:solidFill>
                   <a:srgbClr val="5F574E"/>
                 </a:solidFill>
-                <a:latin typeface="Poppins" pitchFamily="34" charset="0"/>
+                <a:latin typeface="DM Sans 14pt" pitchFamily="34" charset="0"/>
                 <a:ea typeface="Arial" pitchFamily="34" charset="-122"/>
                 <a:cs typeface="Arial" pitchFamily="34" charset="-120"/>
               </a:rPr>
@@ -4682,7 +4682,7 @@
                 <a:solidFill>
                   <a:srgbClr val="151210"/>
                 </a:solidFill>
-                <a:latin typeface="Poppins" pitchFamily="34" charset="0"/>
+                <a:latin typeface="DM Sans 14pt" pitchFamily="34" charset="0"/>
                 <a:ea typeface="Arial" pitchFamily="34" charset="-122"/>
                 <a:cs typeface="Arial" pitchFamily="34" charset="-120"/>
               </a:rPr>
@@ -4699,7 +4699,7 @@
                 <a:solidFill>
                   <a:srgbClr val="151210"/>
                 </a:solidFill>
-                <a:latin typeface="Poppins" pitchFamily="34" charset="0"/>
+                <a:latin typeface="DM Sans 14pt" pitchFamily="34" charset="0"/>
                 <a:ea typeface="Arial" pitchFamily="34" charset="-122"/>
                 <a:cs typeface="Arial" pitchFamily="34" charset="-120"/>
               </a:rPr>
@@ -4716,7 +4716,7 @@
                 <a:solidFill>
                   <a:srgbClr val="151210"/>
                 </a:solidFill>
-                <a:latin typeface="Poppins" pitchFamily="34" charset="0"/>
+                <a:latin typeface="DM Sans 14pt" pitchFamily="34" charset="0"/>
                 <a:ea typeface="Arial" pitchFamily="34" charset="-122"/>
                 <a:cs typeface="Arial" pitchFamily="34" charset="-120"/>
               </a:rPr>
@@ -4784,7 +4784,7 @@
                 <a:solidFill>
                   <a:srgbClr val="151210"/>
                 </a:solidFill>
-                <a:latin typeface="Poppins" pitchFamily="34" charset="0"/>
+                <a:latin typeface="DM Sans 14pt" pitchFamily="34" charset="0"/>
                 <a:ea typeface="Arial" pitchFamily="34" charset="-122"/>
                 <a:cs typeface="Arial" pitchFamily="34" charset="-120"/>
               </a:rPr>
@@ -5049,7 +5049,7 @@
                 <a:solidFill>
                   <a:srgbClr val="FFFFFF"/>
                 </a:solidFill>
-                <a:latin typeface="Poppins" pitchFamily="34" charset="0"/>
+                <a:latin typeface="Playfair Display" pitchFamily="34" charset="0"/>
                 <a:ea typeface="Arial" pitchFamily="34" charset="-122"/>
                 <a:cs typeface="Arial" pitchFamily="34" charset="-120"/>
               </a:rPr>
@@ -5088,7 +5088,7 @@
                 <a:solidFill>
                   <a:srgbClr val="FFFFFF"/>
                 </a:solidFill>
-                <a:latin typeface="Poppins" pitchFamily="34" charset="0"/>
+                <a:latin typeface="DM Sans 14pt" pitchFamily="34" charset="0"/>
                 <a:ea typeface="Arial" pitchFamily="34" charset="-122"/>
                 <a:cs typeface="Arial" pitchFamily="34" charset="-120"/>
               </a:rPr>
@@ -5123,70 +5123,70 @@
               <a:buNone/>
             </a:pPr>
             <a:r>
-              <a:rPr lang="en-US" sz="850" b="1" dirty="0">
+              <a:rPr lang="en-US" sz="850" b="1" dirty="0" spc="60">
                 <a:solidFill>
                   <a:srgbClr val="FFFFFF"/>
                 </a:solidFill>
-                <a:latin typeface="Poppins" pitchFamily="34" charset="0"/>
-                <a:ea typeface="Arial" pitchFamily="34" charset="-122"/>
-                <a:cs typeface="Arial" pitchFamily="34" charset="-120"/>
-              </a:rPr>
-              <a:t>MAN MOTORS S.A.  •  </a:t>
-            </a:r>
-            <a:r>
-              <a:rPr lang="en-US" sz="850" b="1" dirty="0" err="1">
+                <a:latin typeface="DM Sans 14pt" pitchFamily="34" charset="0"/>
+                <a:ea typeface="Arial" pitchFamily="34" charset="-122"/>
+                <a:cs typeface="Arial" pitchFamily="34" charset="-120"/>
+              </a:rPr>
+              <a:t>VENDAS DE ALTA PERFORMANCE  •  O CÓDIGO DAS VENDAS INFALÍVEIS</a:t>
+            </a:r>
+            <a:r>
+              <a:rPr lang="en-US" sz="850" b="1" dirty="0" err="1" spc="60">
                 <a:solidFill>
                   <a:srgbClr val="FFFFFF"/>
                 </a:solidFill>
-                <a:latin typeface="Poppins" pitchFamily="34" charset="0"/>
-                <a:ea typeface="Arial" pitchFamily="34" charset="-122"/>
-                <a:cs typeface="Arial" pitchFamily="34" charset="-120"/>
-              </a:rPr>
-              <a:t>Fuerza</a:t>
-            </a:r>
-            <a:r>
-              <a:rPr lang="en-US" sz="850" b="1" dirty="0">
+                <a:latin typeface="DM Sans 14pt" pitchFamily="34" charset="0"/>
+                <a:ea typeface="Arial" pitchFamily="34" charset="-122"/>
+                <a:cs typeface="Arial" pitchFamily="34" charset="-120"/>
+              </a:rPr>
+              <a:t/>
+            </a:r>
+            <a:r>
+              <a:rPr lang="en-US" sz="850" b="1" dirty="0" spc="60">
                 <a:solidFill>
                   <a:srgbClr val="FFFFFF"/>
                 </a:solidFill>
-                <a:latin typeface="Poppins" pitchFamily="34" charset="0"/>
-                <a:ea typeface="Arial" pitchFamily="34" charset="-122"/>
-                <a:cs typeface="Arial" pitchFamily="34" charset="-120"/>
-              </a:rPr>
-              <a:t> que </a:t>
-            </a:r>
-            <a:r>
-              <a:rPr lang="en-US" sz="850" b="1" dirty="0" err="1">
+                <a:latin typeface="DM Sans 14pt" pitchFamily="34" charset="0"/>
+                <a:ea typeface="Arial" pitchFamily="34" charset="-122"/>
+                <a:cs typeface="Arial" pitchFamily="34" charset="-120"/>
+              </a:rPr>
+              <a:t/>
+            </a:r>
+            <a:r>
+              <a:rPr lang="en-US" sz="850" b="1" dirty="0" err="1" spc="60">
                 <a:solidFill>
                   <a:srgbClr val="FFFFFF"/>
                 </a:solidFill>
-                <a:latin typeface="Poppins" pitchFamily="34" charset="0"/>
-                <a:ea typeface="Arial" pitchFamily="34" charset="-122"/>
-                <a:cs typeface="Arial" pitchFamily="34" charset="-120"/>
-              </a:rPr>
-              <a:t>conecta</a:t>
-            </a:r>
-            <a:r>
-              <a:rPr lang="en-US" sz="850" b="1" dirty="0">
+                <a:latin typeface="DM Sans 14pt" pitchFamily="34" charset="0"/>
+                <a:ea typeface="Arial" pitchFamily="34" charset="-122"/>
+                <a:cs typeface="Arial" pitchFamily="34" charset="-120"/>
+              </a:rPr>
+              <a:t/>
+            </a:r>
+            <a:r>
+              <a:rPr lang="en-US" sz="850" b="1" dirty="0" spc="60">
                 <a:solidFill>
                   <a:srgbClr val="FFFFFF"/>
                 </a:solidFill>
-                <a:latin typeface="Poppins" pitchFamily="34" charset="0"/>
-                <a:ea typeface="Arial" pitchFamily="34" charset="-122"/>
-                <a:cs typeface="Arial" pitchFamily="34" charset="-120"/>
-              </a:rPr>
-              <a:t> </a:t>
-            </a:r>
-            <a:r>
-              <a:rPr lang="en-US" sz="850" b="1" dirty="0" err="1">
+                <a:latin typeface="DM Sans 14pt" pitchFamily="34" charset="0"/>
+                <a:ea typeface="Arial" pitchFamily="34" charset="-122"/>
+                <a:cs typeface="Arial" pitchFamily="34" charset="-120"/>
+              </a:rPr>
+              <a:t/>
+            </a:r>
+            <a:r>
+              <a:rPr lang="en-US" sz="850" b="1" dirty="0" err="1" spc="60">
                 <a:solidFill>
                   <a:srgbClr val="FFFFFF"/>
                 </a:solidFill>
-                <a:latin typeface="Poppins" pitchFamily="34" charset="0"/>
-                <a:ea typeface="Arial" pitchFamily="34" charset="-122"/>
-                <a:cs typeface="Arial" pitchFamily="34" charset="-120"/>
-              </a:rPr>
-              <a:t>caminos</a:t>
+                <a:latin typeface="DM Sans 14pt" pitchFamily="34" charset="0"/>
+                <a:ea typeface="Arial" pitchFamily="34" charset="-122"/>
+                <a:cs typeface="Arial" pitchFamily="34" charset="-120"/>
+              </a:rPr>
+              <a:t/>
             </a:r>
             <a:endParaRPr lang="en-US" sz="850" dirty="0"/>
           </a:p>
@@ -5217,11 +5217,11 @@
               <a:buNone/>
             </a:pPr>
             <a:r>
-              <a:rPr lang="en-US" sz="850" dirty="0">
+              <a:rPr lang="en-US" sz="850" dirty="0" spc="60">
                 <a:solidFill>
                   <a:srgbClr val="FFFFFF"/>
                 </a:solidFill>
-                <a:latin typeface="Poppins" pitchFamily="34" charset="0"/>
+                <a:latin typeface="DM Sans 14pt" pitchFamily="34" charset="0"/>
                 <a:ea typeface="Arial" pitchFamily="34" charset="-122"/>
                 <a:cs typeface="Arial" pitchFamily="34" charset="-120"/>
               </a:rPr>
@@ -5291,7 +5291,7 @@
                 <a:solidFill>
                   <a:srgbClr val="151210"/>
                 </a:solidFill>
-                <a:latin typeface="Poppins" pitchFamily="34" charset="0"/>
+                <a:latin typeface="Playfair Display" pitchFamily="34" charset="0"/>
                 <a:ea typeface="Arial" pitchFamily="34" charset="-122"/>
                 <a:cs typeface="Arial" pitchFamily="34" charset="-120"/>
               </a:rPr>
@@ -5359,7 +5359,7 @@
                 <a:solidFill>
                   <a:srgbClr val="96651A"/>
                 </a:solidFill>
-                <a:latin typeface="Poppins" pitchFamily="34" charset="0"/>
+                <a:latin typeface="Playfair Display" pitchFamily="34" charset="0"/>
                 <a:ea typeface="Arial" pitchFamily="34" charset="-122"/>
                 <a:cs typeface="Arial" pitchFamily="34" charset="-120"/>
               </a:rPr>
@@ -5398,7 +5398,7 @@
                 <a:solidFill>
                   <a:srgbClr val="151210"/>
                 </a:solidFill>
-                <a:latin typeface="Poppins" pitchFamily="34" charset="0"/>
+                <a:latin typeface="DM Sans 14pt" pitchFamily="34" charset="0"/>
                 <a:ea typeface="Arial" pitchFamily="34" charset="-122"/>
                 <a:cs typeface="Arial" pitchFamily="34" charset="-120"/>
               </a:rPr>
@@ -5466,7 +5466,7 @@
                 <a:solidFill>
                   <a:srgbClr val="96651A"/>
                 </a:solidFill>
-                <a:latin typeface="Poppins" pitchFamily="34" charset="0"/>
+                <a:latin typeface="Playfair Display" pitchFamily="34" charset="0"/>
                 <a:ea typeface="Arial" pitchFamily="34" charset="-122"/>
                 <a:cs typeface="Arial" pitchFamily="34" charset="-120"/>
               </a:rPr>
@@ -5505,7 +5505,7 @@
                 <a:solidFill>
                   <a:srgbClr val="151210"/>
                 </a:solidFill>
-                <a:latin typeface="Poppins" pitchFamily="34" charset="0"/>
+                <a:latin typeface="DM Sans 14pt" pitchFamily="34" charset="0"/>
                 <a:ea typeface="Arial" pitchFamily="34" charset="-122"/>
                 <a:cs typeface="Arial" pitchFamily="34" charset="-120"/>
               </a:rPr>
@@ -5573,7 +5573,7 @@
                 <a:solidFill>
                   <a:srgbClr val="151210"/>
                 </a:solidFill>
-                <a:latin typeface="Poppins" pitchFamily="34" charset="0"/>
+                <a:latin typeface="Playfair Display" pitchFamily="34" charset="0"/>
                 <a:ea typeface="Arial" pitchFamily="34" charset="-122"/>
                 <a:cs typeface="Arial" pitchFamily="34" charset="-120"/>
               </a:rPr>
@@ -5612,7 +5612,7 @@
                 <a:solidFill>
                   <a:srgbClr val="151210"/>
                 </a:solidFill>
-                <a:latin typeface="Poppins" pitchFamily="34" charset="0"/>
+                <a:latin typeface="DM Sans 14pt" pitchFamily="34" charset="0"/>
                 <a:ea typeface="Arial" pitchFamily="34" charset="-122"/>
                 <a:cs typeface="Arial" pitchFamily="34" charset="-120"/>
               </a:rPr>
@@ -5680,7 +5680,7 @@
                 <a:solidFill>
                   <a:srgbClr val="96651A"/>
                 </a:solidFill>
-                <a:latin typeface="Poppins" pitchFamily="34" charset="0"/>
+                <a:latin typeface="Playfair Display" pitchFamily="34" charset="0"/>
                 <a:ea typeface="Arial" pitchFamily="34" charset="-122"/>
                 <a:cs typeface="Arial" pitchFamily="34" charset="-120"/>
               </a:rPr>
@@ -5719,7 +5719,7 @@
                 <a:solidFill>
                   <a:srgbClr val="151210"/>
                 </a:solidFill>
-                <a:latin typeface="Poppins" pitchFamily="34" charset="0"/>
+                <a:latin typeface="DM Sans 14pt" pitchFamily="34" charset="0"/>
                 <a:ea typeface="Arial" pitchFamily="34" charset="-122"/>
                 <a:cs typeface="Arial" pitchFamily="34" charset="-120"/>
               </a:rPr>
@@ -5787,7 +5787,7 @@
                 <a:solidFill>
                   <a:srgbClr val="96651A"/>
                 </a:solidFill>
-                <a:latin typeface="Poppins" pitchFamily="34" charset="0"/>
+                <a:latin typeface="Playfair Display" pitchFamily="34" charset="0"/>
                 <a:ea typeface="Arial" pitchFamily="34" charset="-122"/>
                 <a:cs typeface="Arial" pitchFamily="34" charset="-120"/>
               </a:rPr>
@@ -5826,7 +5826,7 @@
                 <a:solidFill>
                   <a:srgbClr val="151210"/>
                 </a:solidFill>
-                <a:latin typeface="Poppins" pitchFamily="34" charset="0"/>
+                <a:latin typeface="DM Sans 14pt" pitchFamily="34" charset="0"/>
                 <a:ea typeface="Arial" pitchFamily="34" charset="-122"/>
                 <a:cs typeface="Arial" pitchFamily="34" charset="-120"/>
               </a:rPr>
@@ -5894,7 +5894,7 @@
                 <a:solidFill>
                   <a:srgbClr val="96651A"/>
                 </a:solidFill>
-                <a:latin typeface="Poppins" pitchFamily="34" charset="0"/>
+                <a:latin typeface="Playfair Display" pitchFamily="34" charset="0"/>
                 <a:ea typeface="Arial" pitchFamily="34" charset="-122"/>
                 <a:cs typeface="Arial" pitchFamily="34" charset="-120"/>
               </a:rPr>
@@ -5933,7 +5933,7 @@
                 <a:solidFill>
                   <a:srgbClr val="151210"/>
                 </a:solidFill>
-                <a:latin typeface="Poppins" pitchFamily="34" charset="0"/>
+                <a:latin typeface="DM Sans 14pt" pitchFamily="34" charset="0"/>
                 <a:ea typeface="Arial" pitchFamily="34" charset="-122"/>
                 <a:cs typeface="Arial" pitchFamily="34" charset="-120"/>
               </a:rPr>
@@ -6001,7 +6001,7 @@
                 <a:solidFill>
                   <a:srgbClr val="96651A"/>
                 </a:solidFill>
-                <a:latin typeface="Poppins" pitchFamily="34" charset="0"/>
+                <a:latin typeface="Playfair Display" pitchFamily="34" charset="0"/>
                 <a:ea typeface="Arial" pitchFamily="34" charset="-122"/>
                 <a:cs typeface="Arial" pitchFamily="34" charset="-120"/>
               </a:rPr>
@@ -6040,7 +6040,7 @@
                 <a:solidFill>
                   <a:srgbClr val="151210"/>
                 </a:solidFill>
-                <a:latin typeface="Poppins" pitchFamily="34" charset="0"/>
+                <a:latin typeface="DM Sans 14pt" pitchFamily="34" charset="0"/>
                 <a:ea typeface="Arial" pitchFamily="34" charset="-122"/>
                 <a:cs typeface="Arial" pitchFamily="34" charset="-120"/>
               </a:rPr>
@@ -6108,7 +6108,7 @@
                 <a:solidFill>
                   <a:srgbClr val="96651A"/>
                 </a:solidFill>
-                <a:latin typeface="Poppins" pitchFamily="34" charset="0"/>
+                <a:latin typeface="Playfair Display" pitchFamily="34" charset="0"/>
                 <a:ea typeface="Arial" pitchFamily="34" charset="-122"/>
                 <a:cs typeface="Arial" pitchFamily="34" charset="-120"/>
               </a:rPr>
@@ -6147,7 +6147,7 @@
                 <a:solidFill>
                   <a:srgbClr val="151210"/>
                 </a:solidFill>
-                <a:latin typeface="Poppins" pitchFamily="34" charset="0"/>
+                <a:latin typeface="DM Sans 14pt" pitchFamily="34" charset="0"/>
                 <a:ea typeface="Arial" pitchFamily="34" charset="-122"/>
                 <a:cs typeface="Arial" pitchFamily="34" charset="-120"/>
               </a:rPr>
@@ -6215,7 +6215,7 @@
                 <a:solidFill>
                   <a:srgbClr val="96651A"/>
                 </a:solidFill>
-                <a:latin typeface="Poppins" pitchFamily="34" charset="0"/>
+                <a:latin typeface="Playfair Display" pitchFamily="34" charset="0"/>
                 <a:ea typeface="Arial" pitchFamily="34" charset="-122"/>
                 <a:cs typeface="Arial" pitchFamily="34" charset="-120"/>
               </a:rPr>
@@ -6254,7 +6254,7 @@
                 <a:solidFill>
                   <a:srgbClr val="151210"/>
                 </a:solidFill>
-                <a:latin typeface="Poppins" pitchFamily="34" charset="0"/>
+                <a:latin typeface="DM Sans 14pt" pitchFamily="34" charset="0"/>
                 <a:ea typeface="Arial" pitchFamily="34" charset="-122"/>
                 <a:cs typeface="Arial" pitchFamily="34" charset="-120"/>
               </a:rPr>
@@ -6322,7 +6322,7 @@
                 <a:solidFill>
                   <a:srgbClr val="FFFFFF"/>
                 </a:solidFill>
-                <a:latin typeface="Poppins" pitchFamily="34" charset="0"/>
+                <a:latin typeface="DM Sans 14pt" pitchFamily="34" charset="0"/>
                 <a:ea typeface="Arial" pitchFamily="34" charset="-122"/>
                 <a:cs typeface="Arial" pitchFamily="34" charset="-120"/>
               </a:rPr>
@@ -6483,7 +6483,7 @@
                 <a:solidFill>
                   <a:srgbClr val="FFFFFF"/>
                 </a:solidFill>
-                <a:latin typeface="Poppins" pitchFamily="34" charset="0"/>
+                <a:latin typeface="Playfair Display" pitchFamily="34" charset="0"/>
                 <a:ea typeface="Arial" pitchFamily="34" charset="-122"/>
                 <a:cs typeface="Arial" pitchFamily="34" charset="-120"/>
               </a:rPr>
@@ -6522,7 +6522,7 @@
                 <a:solidFill>
                   <a:srgbClr val="FFFFFF"/>
                 </a:solidFill>
-                <a:latin typeface="Poppins" pitchFamily="34" charset="0"/>
+                <a:latin typeface="DM Sans 14pt" pitchFamily="34" charset="0"/>
                 <a:ea typeface="Arial" pitchFamily="34" charset="-122"/>
                 <a:cs typeface="Arial" pitchFamily="34" charset="-120"/>
               </a:rPr>
@@ -6557,70 +6557,70 @@
               <a:buNone/>
             </a:pPr>
             <a:r>
-              <a:rPr lang="en-US" sz="850" b="1" dirty="0">
+              <a:rPr lang="en-US" sz="850" b="1" dirty="0" spc="60">
                 <a:solidFill>
                   <a:srgbClr val="FFFFFF"/>
                 </a:solidFill>
-                <a:latin typeface="Poppins" pitchFamily="34" charset="0"/>
-                <a:ea typeface="Arial" pitchFamily="34" charset="-122"/>
-                <a:cs typeface="Arial" pitchFamily="34" charset="-120"/>
-              </a:rPr>
-              <a:t>MAN MOTORS S.A.  •  </a:t>
-            </a:r>
-            <a:r>
-              <a:rPr lang="en-US" sz="850" b="1" dirty="0" err="1">
+                <a:latin typeface="DM Sans 14pt" pitchFamily="34" charset="0"/>
+                <a:ea typeface="Arial" pitchFamily="34" charset="-122"/>
+                <a:cs typeface="Arial" pitchFamily="34" charset="-120"/>
+              </a:rPr>
+              <a:t>VENDAS DE ALTA PERFORMANCE  •  O CÓDIGO DAS VENDAS INFALÍVEIS</a:t>
+            </a:r>
+            <a:r>
+              <a:rPr lang="en-US" sz="850" b="1" dirty="0" err="1" spc="60">
                 <a:solidFill>
                   <a:srgbClr val="FFFFFF"/>
                 </a:solidFill>
-                <a:latin typeface="Poppins" pitchFamily="34" charset="0"/>
-                <a:ea typeface="Arial" pitchFamily="34" charset="-122"/>
-                <a:cs typeface="Arial" pitchFamily="34" charset="-120"/>
-              </a:rPr>
-              <a:t>Fuerza</a:t>
-            </a:r>
-            <a:r>
-              <a:rPr lang="en-US" sz="850" b="1" dirty="0">
+                <a:latin typeface="DM Sans 14pt" pitchFamily="34" charset="0"/>
+                <a:ea typeface="Arial" pitchFamily="34" charset="-122"/>
+                <a:cs typeface="Arial" pitchFamily="34" charset="-120"/>
+              </a:rPr>
+              <a:t/>
+            </a:r>
+            <a:r>
+              <a:rPr lang="en-US" sz="850" b="1" dirty="0" spc="60">
                 <a:solidFill>
                   <a:srgbClr val="FFFFFF"/>
                 </a:solidFill>
-                <a:latin typeface="Poppins" pitchFamily="34" charset="0"/>
-                <a:ea typeface="Arial" pitchFamily="34" charset="-122"/>
-                <a:cs typeface="Arial" pitchFamily="34" charset="-120"/>
-              </a:rPr>
-              <a:t> que </a:t>
-            </a:r>
-            <a:r>
-              <a:rPr lang="en-US" sz="850" b="1" dirty="0" err="1">
+                <a:latin typeface="DM Sans 14pt" pitchFamily="34" charset="0"/>
+                <a:ea typeface="Arial" pitchFamily="34" charset="-122"/>
+                <a:cs typeface="Arial" pitchFamily="34" charset="-120"/>
+              </a:rPr>
+              <a:t/>
+            </a:r>
+            <a:r>
+              <a:rPr lang="en-US" sz="850" b="1" dirty="0" err="1" spc="60">
                 <a:solidFill>
                   <a:srgbClr val="FFFFFF"/>
                 </a:solidFill>
-                <a:latin typeface="Poppins" pitchFamily="34" charset="0"/>
-                <a:ea typeface="Arial" pitchFamily="34" charset="-122"/>
-                <a:cs typeface="Arial" pitchFamily="34" charset="-120"/>
-              </a:rPr>
-              <a:t>connecta</a:t>
-            </a:r>
-            <a:r>
-              <a:rPr lang="en-US" sz="850" b="1" dirty="0">
+                <a:latin typeface="DM Sans 14pt" pitchFamily="34" charset="0"/>
+                <a:ea typeface="Arial" pitchFamily="34" charset="-122"/>
+                <a:cs typeface="Arial" pitchFamily="34" charset="-120"/>
+              </a:rPr>
+              <a:t/>
+            </a:r>
+            <a:r>
+              <a:rPr lang="en-US" sz="850" b="1" dirty="0" spc="60">
                 <a:solidFill>
                   <a:srgbClr val="FFFFFF"/>
                 </a:solidFill>
-                <a:latin typeface="Poppins" pitchFamily="34" charset="0"/>
-                <a:ea typeface="Arial" pitchFamily="34" charset="-122"/>
-                <a:cs typeface="Arial" pitchFamily="34" charset="-120"/>
-              </a:rPr>
-              <a:t> </a:t>
-            </a:r>
-            <a:r>
-              <a:rPr lang="en-US" sz="850" b="1" dirty="0" err="1">
+                <a:latin typeface="DM Sans 14pt" pitchFamily="34" charset="0"/>
+                <a:ea typeface="Arial" pitchFamily="34" charset="-122"/>
+                <a:cs typeface="Arial" pitchFamily="34" charset="-120"/>
+              </a:rPr>
+              <a:t/>
+            </a:r>
+            <a:r>
+              <a:rPr lang="en-US" sz="850" b="1" dirty="0" err="1" spc="60">
                 <a:solidFill>
                   <a:srgbClr val="FFFFFF"/>
                 </a:solidFill>
-                <a:latin typeface="Poppins" pitchFamily="34" charset="0"/>
-                <a:ea typeface="Arial" pitchFamily="34" charset="-122"/>
-                <a:cs typeface="Arial" pitchFamily="34" charset="-120"/>
-              </a:rPr>
-              <a:t>caminos</a:t>
+                <a:latin typeface="DM Sans 14pt" pitchFamily="34" charset="0"/>
+                <a:ea typeface="Arial" pitchFamily="34" charset="-122"/>
+                <a:cs typeface="Arial" pitchFamily="34" charset="-120"/>
+              </a:rPr>
+              <a:t/>
             </a:r>
             <a:endParaRPr lang="en-US" sz="850" dirty="0"/>
           </a:p>
@@ -6651,11 +6651,11 @@
               <a:buNone/>
             </a:pPr>
             <a:r>
-              <a:rPr lang="en-US" sz="850" dirty="0">
+              <a:rPr lang="en-US" sz="850" dirty="0" spc="60">
                 <a:solidFill>
                   <a:srgbClr val="FFFFFF"/>
                 </a:solidFill>
-                <a:latin typeface="Poppins" pitchFamily="34" charset="0"/>
+                <a:latin typeface="DM Sans 14pt" pitchFamily="34" charset="0"/>
                 <a:ea typeface="Arial" pitchFamily="34" charset="-122"/>
                 <a:cs typeface="Arial" pitchFamily="34" charset="-120"/>
               </a:rPr>
@@ -6752,7 +6752,7 @@
                 <a:solidFill>
                   <a:srgbClr val="151210"/>
                 </a:solidFill>
-                <a:latin typeface="Poppins" pitchFamily="34" charset="0"/>
+                <a:latin typeface="Playfair Display" pitchFamily="34" charset="0"/>
                 <a:ea typeface="Arial" pitchFamily="34" charset="-122"/>
                 <a:cs typeface="Arial" pitchFamily="34" charset="-120"/>
               </a:rPr>
@@ -6791,7 +6791,7 @@
                 <a:solidFill>
                   <a:srgbClr val="C08A2A"/>
                 </a:solidFill>
-                <a:latin typeface="Poppins" pitchFamily="34" charset="0"/>
+                <a:latin typeface="DM Sans 14pt" pitchFamily="34" charset="0"/>
                 <a:ea typeface="Arial" pitchFamily="34" charset="-122"/>
                 <a:cs typeface="Arial" pitchFamily="34" charset="-120"/>
               </a:rPr>
@@ -6832,7 +6832,7 @@
                 <a:solidFill>
                   <a:srgbClr val="151210"/>
                 </a:solidFill>
-                <a:latin typeface="Poppins" pitchFamily="34" charset="0"/>
+                <a:latin typeface="Playfair Display" pitchFamily="34" charset="0"/>
                 <a:ea typeface="Arial" pitchFamily="34" charset="-122"/>
                 <a:cs typeface="Arial" pitchFamily="34" charset="-120"/>
               </a:rPr>
@@ -6873,7 +6873,7 @@
                 <a:solidFill>
                   <a:srgbClr val="151210"/>
                 </a:solidFill>
-                <a:latin typeface="Poppins" pitchFamily="34" charset="0"/>
+                <a:latin typeface="DM Sans 14pt" pitchFamily="34" charset="0"/>
                 <a:ea typeface="Arial" pitchFamily="34" charset="-122"/>
                 <a:cs typeface="Arial" pitchFamily="34" charset="-120"/>
               </a:rPr>
@@ -6939,7 +6939,7 @@
                 <a:solidFill>
                   <a:srgbClr val="96651A"/>
                 </a:solidFill>
-                <a:latin typeface="Poppins" pitchFamily="34" charset="0"/>
+                <a:latin typeface="Playfair Display" pitchFamily="34" charset="0"/>
                 <a:ea typeface="Arial" pitchFamily="34" charset="-122"/>
                 <a:cs typeface="Arial" pitchFamily="34" charset="-120"/>
               </a:rPr>
@@ -6980,7 +6980,7 @@
                 <a:solidFill>
                   <a:srgbClr val="151210"/>
                 </a:solidFill>
-                <a:latin typeface="Poppins" pitchFamily="34" charset="0"/>
+                <a:latin typeface="DM Sans 14pt" pitchFamily="34" charset="0"/>
                 <a:ea typeface="Arial" pitchFamily="34" charset="-122"/>
                 <a:cs typeface="Arial" pitchFamily="34" charset="-120"/>
               </a:rPr>
@@ -6997,7 +6997,7 @@
                 <a:solidFill>
                   <a:srgbClr val="151210"/>
                 </a:solidFill>
-                <a:latin typeface="Poppins" pitchFamily="34" charset="0"/>
+                <a:latin typeface="DM Sans 14pt" pitchFamily="34" charset="0"/>
                 <a:ea typeface="Arial" pitchFamily="34" charset="-122"/>
                 <a:cs typeface="Arial" pitchFamily="34" charset="-120"/>
               </a:rPr>
@@ -7014,7 +7014,7 @@
                 <a:solidFill>
                   <a:srgbClr val="151210"/>
                 </a:solidFill>
-                <a:latin typeface="Poppins" pitchFamily="34" charset="0"/>
+                <a:latin typeface="DM Sans 14pt" pitchFamily="34" charset="0"/>
                 <a:ea typeface="Arial" pitchFamily="34" charset="-122"/>
                 <a:cs typeface="Arial" pitchFamily="34" charset="-120"/>
               </a:rPr>
@@ -7082,7 +7082,7 @@
                 <a:solidFill>
                   <a:srgbClr val="151210"/>
                 </a:solidFill>
-                <a:latin typeface="Poppins" pitchFamily="34" charset="0"/>
+                <a:latin typeface="Playfair Display" pitchFamily="34" charset="0"/>
                 <a:ea typeface="Arial" pitchFamily="34" charset="-122"/>
                 <a:cs typeface="Arial" pitchFamily="34" charset="-120"/>
               </a:rPr>
@@ -7123,7 +7123,7 @@
                 <a:solidFill>
                   <a:srgbClr val="96651A"/>
                 </a:solidFill>
-                <a:latin typeface="Poppins" pitchFamily="34" charset="0"/>
+                <a:latin typeface="Playfair Display" pitchFamily="34" charset="0"/>
                 <a:ea typeface="Arial" pitchFamily="34" charset="-122"/>
                 <a:cs typeface="Arial" pitchFamily="34" charset="-120"/>
               </a:rPr>
@@ -7187,11 +7187,11 @@
               <a:buNone/>
             </a:pPr>
             <a:r>
-              <a:rPr lang="en-US" sz="1000" b="1" dirty="0">
+              <a:rPr lang="en-US" sz="1000" b="1" dirty="0" spc="60">
                 <a:solidFill>
                   <a:srgbClr val="E6BD5E"/>
                 </a:solidFill>
-                <a:latin typeface="Poppins" pitchFamily="34" charset="0"/>
+                <a:latin typeface="DM Sans 14pt" pitchFamily="34" charset="0"/>
                 <a:ea typeface="Arial" pitchFamily="34" charset="-122"/>
                 <a:cs typeface="Arial" pitchFamily="34" charset="-120"/>
               </a:rPr>
@@ -7232,7 +7232,7 @@
                 <a:solidFill>
                   <a:srgbClr val="FFFFFF"/>
                 </a:solidFill>
-                <a:latin typeface="Poppins" pitchFamily="34" charset="0"/>
+                <a:latin typeface="DM Sans 14pt" pitchFamily="34" charset="0"/>
                 <a:ea typeface="Arial" pitchFamily="34" charset="-122"/>
                 <a:cs typeface="Arial" pitchFamily="34" charset="-120"/>
               </a:rPr>
@@ -7393,7 +7393,7 @@
                 <a:solidFill>
                   <a:srgbClr val="FFFFFF"/>
                 </a:solidFill>
-                <a:latin typeface="Poppins" pitchFamily="34" charset="0"/>
+                <a:latin typeface="Playfair Display" pitchFamily="34" charset="0"/>
                 <a:ea typeface="Arial" pitchFamily="34" charset="-122"/>
                 <a:cs typeface="Arial" pitchFamily="34" charset="-120"/>
               </a:rPr>
@@ -7432,7 +7432,7 @@
                 <a:solidFill>
                   <a:srgbClr val="FFFFFF"/>
                 </a:solidFill>
-                <a:latin typeface="Poppins" pitchFamily="34" charset="0"/>
+                <a:latin typeface="DM Sans 14pt" pitchFamily="34" charset="0"/>
                 <a:ea typeface="Arial" pitchFamily="34" charset="-122"/>
                 <a:cs typeface="Arial" pitchFamily="34" charset="-120"/>
               </a:rPr>
@@ -7467,70 +7467,70 @@
               <a:buNone/>
             </a:pPr>
             <a:r>
-              <a:rPr lang="en-US" sz="850" b="1" dirty="0">
+              <a:rPr lang="en-US" sz="850" b="1" dirty="0" spc="60">
                 <a:solidFill>
                   <a:srgbClr val="FFFFFF"/>
                 </a:solidFill>
-                <a:latin typeface="Poppins" pitchFamily="34" charset="0"/>
-                <a:ea typeface="Arial" pitchFamily="34" charset="-122"/>
-                <a:cs typeface="Arial" pitchFamily="34" charset="-120"/>
-              </a:rPr>
-              <a:t>MAN MOTORS S.A.  •  </a:t>
-            </a:r>
-            <a:r>
-              <a:rPr lang="en-US" sz="850" b="1" dirty="0" err="1">
+                <a:latin typeface="DM Sans 14pt" pitchFamily="34" charset="0"/>
+                <a:ea typeface="Arial" pitchFamily="34" charset="-122"/>
+                <a:cs typeface="Arial" pitchFamily="34" charset="-120"/>
+              </a:rPr>
+              <a:t>VENDAS DE ALTA PERFORMANCE  •  O CÓDIGO DAS VENDAS INFALÍVEIS</a:t>
+            </a:r>
+            <a:r>
+              <a:rPr lang="en-US" sz="850" b="1" dirty="0" err="1" spc="60">
                 <a:solidFill>
                   <a:srgbClr val="FFFFFF"/>
                 </a:solidFill>
-                <a:latin typeface="Poppins" pitchFamily="34" charset="0"/>
-                <a:ea typeface="Arial" pitchFamily="34" charset="-122"/>
-                <a:cs typeface="Arial" pitchFamily="34" charset="-120"/>
-              </a:rPr>
-              <a:t>Fuerza</a:t>
-            </a:r>
-            <a:r>
-              <a:rPr lang="en-US" sz="850" b="1" dirty="0">
+                <a:latin typeface="DM Sans 14pt" pitchFamily="34" charset="0"/>
+                <a:ea typeface="Arial" pitchFamily="34" charset="-122"/>
+                <a:cs typeface="Arial" pitchFamily="34" charset="-120"/>
+              </a:rPr>
+              <a:t/>
+            </a:r>
+            <a:r>
+              <a:rPr lang="en-US" sz="850" b="1" dirty="0" spc="60">
                 <a:solidFill>
                   <a:srgbClr val="FFFFFF"/>
                 </a:solidFill>
-                <a:latin typeface="Poppins" pitchFamily="34" charset="0"/>
-                <a:ea typeface="Arial" pitchFamily="34" charset="-122"/>
-                <a:cs typeface="Arial" pitchFamily="34" charset="-120"/>
-              </a:rPr>
-              <a:t> que </a:t>
-            </a:r>
-            <a:r>
-              <a:rPr lang="en-US" sz="850" b="1" dirty="0" err="1">
+                <a:latin typeface="DM Sans 14pt" pitchFamily="34" charset="0"/>
+                <a:ea typeface="Arial" pitchFamily="34" charset="-122"/>
+                <a:cs typeface="Arial" pitchFamily="34" charset="-120"/>
+              </a:rPr>
+              <a:t/>
+            </a:r>
+            <a:r>
+              <a:rPr lang="en-US" sz="850" b="1" dirty="0" err="1" spc="60">
                 <a:solidFill>
                   <a:srgbClr val="FFFFFF"/>
                 </a:solidFill>
-                <a:latin typeface="Poppins" pitchFamily="34" charset="0"/>
-                <a:ea typeface="Arial" pitchFamily="34" charset="-122"/>
-                <a:cs typeface="Arial" pitchFamily="34" charset="-120"/>
-              </a:rPr>
-              <a:t>conecta</a:t>
-            </a:r>
-            <a:r>
-              <a:rPr lang="en-US" sz="850" b="1" dirty="0">
+                <a:latin typeface="DM Sans 14pt" pitchFamily="34" charset="0"/>
+                <a:ea typeface="Arial" pitchFamily="34" charset="-122"/>
+                <a:cs typeface="Arial" pitchFamily="34" charset="-120"/>
+              </a:rPr>
+              <a:t/>
+            </a:r>
+            <a:r>
+              <a:rPr lang="en-US" sz="850" b="1" dirty="0" spc="60">
                 <a:solidFill>
                   <a:srgbClr val="FFFFFF"/>
                 </a:solidFill>
-                <a:latin typeface="Poppins" pitchFamily="34" charset="0"/>
-                <a:ea typeface="Arial" pitchFamily="34" charset="-122"/>
-                <a:cs typeface="Arial" pitchFamily="34" charset="-120"/>
-              </a:rPr>
-              <a:t> </a:t>
-            </a:r>
-            <a:r>
-              <a:rPr lang="en-US" sz="850" b="1" dirty="0" err="1">
+                <a:latin typeface="DM Sans 14pt" pitchFamily="34" charset="0"/>
+                <a:ea typeface="Arial" pitchFamily="34" charset="-122"/>
+                <a:cs typeface="Arial" pitchFamily="34" charset="-120"/>
+              </a:rPr>
+              <a:t/>
+            </a:r>
+            <a:r>
+              <a:rPr lang="en-US" sz="850" b="1" dirty="0" err="1" spc="60">
                 <a:solidFill>
                   <a:srgbClr val="FFFFFF"/>
                 </a:solidFill>
-                <a:latin typeface="Poppins" pitchFamily="34" charset="0"/>
-                <a:ea typeface="Arial" pitchFamily="34" charset="-122"/>
-                <a:cs typeface="Arial" pitchFamily="34" charset="-120"/>
-              </a:rPr>
-              <a:t>caminos</a:t>
+                <a:latin typeface="DM Sans 14pt" pitchFamily="34" charset="0"/>
+                <a:ea typeface="Arial" pitchFamily="34" charset="-122"/>
+                <a:cs typeface="Arial" pitchFamily="34" charset="-120"/>
+              </a:rPr>
+              <a:t/>
             </a:r>
             <a:endParaRPr lang="en-US" sz="850" dirty="0"/>
           </a:p>
@@ -7561,11 +7561,11 @@
               <a:buNone/>
             </a:pPr>
             <a:r>
-              <a:rPr lang="en-US" sz="850" dirty="0">
+              <a:rPr lang="en-US" sz="850" dirty="0" spc="60">
                 <a:solidFill>
                   <a:srgbClr val="FFFFFF"/>
                 </a:solidFill>
-                <a:latin typeface="Poppins" pitchFamily="34" charset="0"/>
+                <a:latin typeface="DM Sans 14pt" pitchFamily="34" charset="0"/>
                 <a:ea typeface="Arial" pitchFamily="34" charset="-122"/>
                 <a:cs typeface="Arial" pitchFamily="34" charset="-120"/>
               </a:rPr>
@@ -7662,7 +7662,7 @@
                 <a:solidFill>
                   <a:srgbClr val="151210"/>
                 </a:solidFill>
-                <a:latin typeface="Poppins" pitchFamily="34" charset="0"/>
+                <a:latin typeface="Playfair Display" pitchFamily="34" charset="0"/>
                 <a:ea typeface="Arial" pitchFamily="34" charset="-122"/>
                 <a:cs typeface="Arial" pitchFamily="34" charset="-120"/>
               </a:rPr>
@@ -7701,7 +7701,7 @@
                 <a:solidFill>
                   <a:srgbClr val="C08A2A"/>
                 </a:solidFill>
-                <a:latin typeface="Poppins" pitchFamily="34" charset="0"/>
+                <a:latin typeface="DM Sans 14pt" pitchFamily="34" charset="0"/>
                 <a:ea typeface="Arial" pitchFamily="34" charset="-122"/>
                 <a:cs typeface="Arial" pitchFamily="34" charset="-120"/>
               </a:rPr>
@@ -7742,7 +7742,7 @@
                 <a:solidFill>
                   <a:srgbClr val="151210"/>
                 </a:solidFill>
-                <a:latin typeface="Poppins" pitchFamily="34" charset="0"/>
+                <a:latin typeface="Playfair Display" pitchFamily="34" charset="0"/>
                 <a:ea typeface="Arial" pitchFamily="34" charset="-122"/>
                 <a:cs typeface="Arial" pitchFamily="34" charset="-120"/>
               </a:rPr>
@@ -7783,7 +7783,7 @@
                 <a:solidFill>
                   <a:srgbClr val="151210"/>
                 </a:solidFill>
-                <a:latin typeface="Poppins" pitchFamily="34" charset="0"/>
+                <a:latin typeface="DM Sans 14pt" pitchFamily="34" charset="0"/>
                 <a:ea typeface="Arial" pitchFamily="34" charset="-122"/>
                 <a:cs typeface="Arial" pitchFamily="34" charset="-120"/>
               </a:rPr>
@@ -7849,7 +7849,7 @@
                 <a:solidFill>
                   <a:srgbClr val="96651A"/>
                 </a:solidFill>
-                <a:latin typeface="Poppins" pitchFamily="34" charset="0"/>
+                <a:latin typeface="Playfair Display" pitchFamily="34" charset="0"/>
                 <a:ea typeface="Arial" pitchFamily="34" charset="-122"/>
                 <a:cs typeface="Arial" pitchFamily="34" charset="-120"/>
               </a:rPr>
@@ -7890,7 +7890,7 @@
                 <a:solidFill>
                   <a:srgbClr val="151210"/>
                 </a:solidFill>
-                <a:latin typeface="Poppins" pitchFamily="34" charset="0"/>
+                <a:latin typeface="DM Sans 14pt" pitchFamily="34" charset="0"/>
                 <a:ea typeface="Arial" pitchFamily="34" charset="-122"/>
                 <a:cs typeface="Arial" pitchFamily="34" charset="-120"/>
               </a:rPr>
@@ -7907,7 +7907,7 @@
                 <a:solidFill>
                   <a:srgbClr val="151210"/>
                 </a:solidFill>
-                <a:latin typeface="Poppins" pitchFamily="34" charset="0"/>
+                <a:latin typeface="DM Sans 14pt" pitchFamily="34" charset="0"/>
                 <a:ea typeface="Arial" pitchFamily="34" charset="-122"/>
                 <a:cs typeface="Arial" pitchFamily="34" charset="-120"/>
               </a:rPr>
@@ -7924,7 +7924,7 @@
                 <a:solidFill>
                   <a:srgbClr val="151210"/>
                 </a:solidFill>
-                <a:latin typeface="Poppins" pitchFamily="34" charset="0"/>
+                <a:latin typeface="DM Sans 14pt" pitchFamily="34" charset="0"/>
                 <a:ea typeface="Arial" pitchFamily="34" charset="-122"/>
                 <a:cs typeface="Arial" pitchFamily="34" charset="-120"/>
               </a:rPr>
@@ -7941,7 +7941,7 @@
                 <a:solidFill>
                   <a:srgbClr val="151210"/>
                 </a:solidFill>
-                <a:latin typeface="Poppins" pitchFamily="34" charset="0"/>
+                <a:latin typeface="DM Sans 14pt" pitchFamily="34" charset="0"/>
                 <a:ea typeface="Arial" pitchFamily="34" charset="-122"/>
                 <a:cs typeface="Arial" pitchFamily="34" charset="-120"/>
               </a:rPr>
@@ -8009,7 +8009,7 @@
                 <a:solidFill>
                   <a:srgbClr val="151210"/>
                 </a:solidFill>
-                <a:latin typeface="Poppins" pitchFamily="34" charset="0"/>
+                <a:latin typeface="Playfair Display" pitchFamily="34" charset="0"/>
                 <a:ea typeface="Arial" pitchFamily="34" charset="-122"/>
                 <a:cs typeface="Arial" pitchFamily="34" charset="-120"/>
               </a:rPr>
@@ -8050,7 +8050,7 @@
                 <a:solidFill>
                   <a:srgbClr val="96651A"/>
                 </a:solidFill>
-                <a:latin typeface="Poppins" pitchFamily="34" charset="0"/>
+                <a:latin typeface="Playfair Display" pitchFamily="34" charset="0"/>
                 <a:ea typeface="Arial" pitchFamily="34" charset="-122"/>
                 <a:cs typeface="Arial" pitchFamily="34" charset="-120"/>
               </a:rPr>
@@ -8114,11 +8114,11 @@
               <a:buNone/>
             </a:pPr>
             <a:r>
-              <a:rPr lang="en-US" sz="1000" b="1" dirty="0">
+              <a:rPr lang="en-US" sz="1000" b="1" dirty="0" spc="60">
                 <a:solidFill>
                   <a:srgbClr val="E6BD5E"/>
                 </a:solidFill>
-                <a:latin typeface="Poppins" pitchFamily="34" charset="0"/>
+                <a:latin typeface="DM Sans 14pt" pitchFamily="34" charset="0"/>
                 <a:ea typeface="Arial" pitchFamily="34" charset="-122"/>
                 <a:cs typeface="Arial" pitchFamily="34" charset="-120"/>
               </a:rPr>
@@ -8159,7 +8159,7 @@
                 <a:solidFill>
                   <a:srgbClr val="FFFFFF"/>
                 </a:solidFill>
-                <a:latin typeface="Poppins" pitchFamily="34" charset="0"/>
+                <a:latin typeface="DM Sans 14pt" pitchFamily="34" charset="0"/>
                 <a:ea typeface="Arial" pitchFamily="34" charset="-122"/>
                 <a:cs typeface="Arial" pitchFamily="34" charset="-120"/>
               </a:rPr>
@@ -8320,7 +8320,7 @@
                 <a:solidFill>
                   <a:srgbClr val="FFFFFF"/>
                 </a:solidFill>
-                <a:latin typeface="Poppins" pitchFamily="34" charset="0"/>
+                <a:latin typeface="Playfair Display" pitchFamily="34" charset="0"/>
                 <a:ea typeface="Arial" pitchFamily="34" charset="-122"/>
                 <a:cs typeface="Arial" pitchFamily="34" charset="-120"/>
               </a:rPr>
@@ -8359,7 +8359,7 @@
                 <a:solidFill>
                   <a:srgbClr val="FFFFFF"/>
                 </a:solidFill>
-                <a:latin typeface="Poppins" pitchFamily="34" charset="0"/>
+                <a:latin typeface="DM Sans 14pt" pitchFamily="34" charset="0"/>
                 <a:ea typeface="Arial" pitchFamily="34" charset="-122"/>
                 <a:cs typeface="Arial" pitchFamily="34" charset="-120"/>
               </a:rPr>
@@ -8394,70 +8394,70 @@
               <a:buNone/>
             </a:pPr>
             <a:r>
-              <a:rPr lang="en-US" sz="850" b="1" dirty="0">
+              <a:rPr lang="en-US" sz="850" b="1" dirty="0" spc="60">
                 <a:solidFill>
                   <a:srgbClr val="FFFFFF"/>
                 </a:solidFill>
-                <a:latin typeface="Poppins" pitchFamily="34" charset="0"/>
-                <a:ea typeface="Arial" pitchFamily="34" charset="-122"/>
-                <a:cs typeface="Arial" pitchFamily="34" charset="-120"/>
-              </a:rPr>
-              <a:t>MAN MOTORS S.A.  •  </a:t>
-            </a:r>
-            <a:r>
-              <a:rPr lang="en-US" sz="850" b="1" dirty="0" err="1">
+                <a:latin typeface="DM Sans 14pt" pitchFamily="34" charset="0"/>
+                <a:ea typeface="Arial" pitchFamily="34" charset="-122"/>
+                <a:cs typeface="Arial" pitchFamily="34" charset="-120"/>
+              </a:rPr>
+              <a:t>VENDAS DE ALTA PERFORMANCE  •  O CÓDIGO DAS VENDAS INFALÍVEIS</a:t>
+            </a:r>
+            <a:r>
+              <a:rPr lang="en-US" sz="850" b="1" dirty="0" err="1" spc="60">
                 <a:solidFill>
                   <a:srgbClr val="FFFFFF"/>
                 </a:solidFill>
-                <a:latin typeface="Poppins" pitchFamily="34" charset="0"/>
-                <a:ea typeface="Arial" pitchFamily="34" charset="-122"/>
-                <a:cs typeface="Arial" pitchFamily="34" charset="-120"/>
-              </a:rPr>
-              <a:t>Fuerza</a:t>
-            </a:r>
-            <a:r>
-              <a:rPr lang="en-US" sz="850" b="1" dirty="0">
+                <a:latin typeface="DM Sans 14pt" pitchFamily="34" charset="0"/>
+                <a:ea typeface="Arial" pitchFamily="34" charset="-122"/>
+                <a:cs typeface="Arial" pitchFamily="34" charset="-120"/>
+              </a:rPr>
+              <a:t/>
+            </a:r>
+            <a:r>
+              <a:rPr lang="en-US" sz="850" b="1" dirty="0" spc="60">
                 <a:solidFill>
                   <a:srgbClr val="FFFFFF"/>
                 </a:solidFill>
-                <a:latin typeface="Poppins" pitchFamily="34" charset="0"/>
-                <a:ea typeface="Arial" pitchFamily="34" charset="-122"/>
-                <a:cs typeface="Arial" pitchFamily="34" charset="-120"/>
-              </a:rPr>
-              <a:t> que </a:t>
-            </a:r>
-            <a:r>
-              <a:rPr lang="en-US" sz="850" b="1" dirty="0" err="1">
+                <a:latin typeface="DM Sans 14pt" pitchFamily="34" charset="0"/>
+                <a:ea typeface="Arial" pitchFamily="34" charset="-122"/>
+                <a:cs typeface="Arial" pitchFamily="34" charset="-120"/>
+              </a:rPr>
+              <a:t/>
+            </a:r>
+            <a:r>
+              <a:rPr lang="en-US" sz="850" b="1" dirty="0" err="1" spc="60">
                 <a:solidFill>
                   <a:srgbClr val="FFFFFF"/>
                 </a:solidFill>
-                <a:latin typeface="Poppins" pitchFamily="34" charset="0"/>
-                <a:ea typeface="Arial" pitchFamily="34" charset="-122"/>
-                <a:cs typeface="Arial" pitchFamily="34" charset="-120"/>
-              </a:rPr>
-              <a:t>conecta</a:t>
-            </a:r>
-            <a:r>
-              <a:rPr lang="en-US" sz="850" b="1" dirty="0">
+                <a:latin typeface="DM Sans 14pt" pitchFamily="34" charset="0"/>
+                <a:ea typeface="Arial" pitchFamily="34" charset="-122"/>
+                <a:cs typeface="Arial" pitchFamily="34" charset="-120"/>
+              </a:rPr>
+              <a:t/>
+            </a:r>
+            <a:r>
+              <a:rPr lang="en-US" sz="850" b="1" dirty="0" spc="60">
                 <a:solidFill>
                   <a:srgbClr val="FFFFFF"/>
                 </a:solidFill>
-                <a:latin typeface="Poppins" pitchFamily="34" charset="0"/>
-                <a:ea typeface="Arial" pitchFamily="34" charset="-122"/>
-                <a:cs typeface="Arial" pitchFamily="34" charset="-120"/>
-              </a:rPr>
-              <a:t> </a:t>
-            </a:r>
-            <a:r>
-              <a:rPr lang="en-US" sz="850" b="1" dirty="0" err="1">
+                <a:latin typeface="DM Sans 14pt" pitchFamily="34" charset="0"/>
+                <a:ea typeface="Arial" pitchFamily="34" charset="-122"/>
+                <a:cs typeface="Arial" pitchFamily="34" charset="-120"/>
+              </a:rPr>
+              <a:t/>
+            </a:r>
+            <a:r>
+              <a:rPr lang="en-US" sz="850" b="1" dirty="0" err="1" spc="60">
                 <a:solidFill>
                   <a:srgbClr val="FFFFFF"/>
                 </a:solidFill>
-                <a:latin typeface="Poppins" pitchFamily="34" charset="0"/>
-                <a:ea typeface="Arial" pitchFamily="34" charset="-122"/>
-                <a:cs typeface="Arial" pitchFamily="34" charset="-120"/>
-              </a:rPr>
-              <a:t>caminos</a:t>
+                <a:latin typeface="DM Sans 14pt" pitchFamily="34" charset="0"/>
+                <a:ea typeface="Arial" pitchFamily="34" charset="-122"/>
+                <a:cs typeface="Arial" pitchFamily="34" charset="-120"/>
+              </a:rPr>
+              <a:t/>
             </a:r>
             <a:endParaRPr lang="en-US" sz="850" dirty="0"/>
           </a:p>
@@ -8488,11 +8488,11 @@
               <a:buNone/>
             </a:pPr>
             <a:r>
-              <a:rPr lang="en-US" sz="850" dirty="0">
+              <a:rPr lang="en-US" sz="850" dirty="0" spc="60">
                 <a:solidFill>
                   <a:srgbClr val="FFFFFF"/>
                 </a:solidFill>
-                <a:latin typeface="Poppins" pitchFamily="34" charset="0"/>
+                <a:latin typeface="DM Sans 14pt" pitchFamily="34" charset="0"/>
                 <a:ea typeface="Arial" pitchFamily="34" charset="-122"/>
                 <a:cs typeface="Arial" pitchFamily="34" charset="-120"/>
               </a:rPr>
@@ -8589,7 +8589,7 @@
                 <a:solidFill>
                   <a:srgbClr val="151210"/>
                 </a:solidFill>
-                <a:latin typeface="Poppins" pitchFamily="34" charset="0"/>
+                <a:latin typeface="Playfair Display" pitchFamily="34" charset="0"/>
                 <a:ea typeface="Arial" pitchFamily="34" charset="-122"/>
                 <a:cs typeface="Arial" pitchFamily="34" charset="-120"/>
               </a:rPr>
@@ -8628,7 +8628,7 @@
                 <a:solidFill>
                   <a:srgbClr val="C08A2A"/>
                 </a:solidFill>
-                <a:latin typeface="Poppins" pitchFamily="34" charset="0"/>
+                <a:latin typeface="DM Sans 14pt" pitchFamily="34" charset="0"/>
                 <a:ea typeface="Arial" pitchFamily="34" charset="-122"/>
                 <a:cs typeface="Arial" pitchFamily="34" charset="-120"/>
               </a:rPr>
@@ -8669,7 +8669,7 @@
                 <a:solidFill>
                   <a:srgbClr val="151210"/>
                 </a:solidFill>
-                <a:latin typeface="Poppins" pitchFamily="34" charset="0"/>
+                <a:latin typeface="Playfair Display" pitchFamily="34" charset="0"/>
                 <a:ea typeface="Arial" pitchFamily="34" charset="-122"/>
                 <a:cs typeface="Arial" pitchFamily="34" charset="-120"/>
               </a:rPr>
@@ -8710,7 +8710,7 @@
                 <a:solidFill>
                   <a:srgbClr val="151210"/>
                 </a:solidFill>
-                <a:latin typeface="Poppins" pitchFamily="34" charset="0"/>
+                <a:latin typeface="DM Sans 14pt" pitchFamily="34" charset="0"/>
                 <a:ea typeface="Arial" pitchFamily="34" charset="-122"/>
                 <a:cs typeface="Arial" pitchFamily="34" charset="-120"/>
               </a:rPr>
@@ -8776,7 +8776,7 @@
                 <a:solidFill>
                   <a:srgbClr val="96651A"/>
                 </a:solidFill>
-                <a:latin typeface="Poppins" pitchFamily="34" charset="0"/>
+                <a:latin typeface="Playfair Display" pitchFamily="34" charset="0"/>
                 <a:ea typeface="Arial" pitchFamily="34" charset="-122"/>
                 <a:cs typeface="Arial" pitchFamily="34" charset="-120"/>
               </a:rPr>
@@ -8817,7 +8817,7 @@
                 <a:solidFill>
                   <a:srgbClr val="151210"/>
                 </a:solidFill>
-                <a:latin typeface="Poppins" pitchFamily="34" charset="0"/>
+                <a:latin typeface="DM Sans 14pt" pitchFamily="34" charset="0"/>
                 <a:ea typeface="Arial" pitchFamily="34" charset="-122"/>
                 <a:cs typeface="Arial" pitchFamily="34" charset="-120"/>
               </a:rPr>
@@ -8834,7 +8834,7 @@
                 <a:solidFill>
                   <a:srgbClr val="151210"/>
                 </a:solidFill>
-                <a:latin typeface="Poppins" pitchFamily="34" charset="0"/>
+                <a:latin typeface="DM Sans 14pt" pitchFamily="34" charset="0"/>
                 <a:ea typeface="Arial" pitchFamily="34" charset="-122"/>
                 <a:cs typeface="Arial" pitchFamily="34" charset="-120"/>
               </a:rPr>
@@ -8851,7 +8851,7 @@
                 <a:solidFill>
                   <a:srgbClr val="151210"/>
                 </a:solidFill>
-                <a:latin typeface="Poppins" pitchFamily="34" charset="0"/>
+                <a:latin typeface="DM Sans 14pt" pitchFamily="34" charset="0"/>
                 <a:ea typeface="Arial" pitchFamily="34" charset="-122"/>
                 <a:cs typeface="Arial" pitchFamily="34" charset="-120"/>
               </a:rPr>
@@ -8919,7 +8919,7 @@
                 <a:solidFill>
                   <a:srgbClr val="151210"/>
                 </a:solidFill>
-                <a:latin typeface="Poppins" pitchFamily="34" charset="0"/>
+                <a:latin typeface="Playfair Display" pitchFamily="34" charset="0"/>
                 <a:ea typeface="Arial" pitchFamily="34" charset="-122"/>
                 <a:cs typeface="Arial" pitchFamily="34" charset="-120"/>
               </a:rPr>
@@ -8960,7 +8960,7 @@
                 <a:solidFill>
                   <a:srgbClr val="96651A"/>
                 </a:solidFill>
-                <a:latin typeface="Poppins" pitchFamily="34" charset="0"/>
+                <a:latin typeface="Playfair Display" pitchFamily="34" charset="0"/>
                 <a:ea typeface="Arial" pitchFamily="34" charset="-122"/>
                 <a:cs typeface="Arial" pitchFamily="34" charset="-120"/>
               </a:rPr>
@@ -9024,11 +9024,11 @@
               <a:buNone/>
             </a:pPr>
             <a:r>
-              <a:rPr lang="en-US" sz="1000" b="1" dirty="0">
+              <a:rPr lang="en-US" sz="1000" b="1" dirty="0" spc="60">
                 <a:solidFill>
                   <a:srgbClr val="E6BD5E"/>
                 </a:solidFill>
-                <a:latin typeface="Poppins" pitchFamily="34" charset="0"/>
+                <a:latin typeface="DM Sans 14pt" pitchFamily="34" charset="0"/>
                 <a:ea typeface="Arial" pitchFamily="34" charset="-122"/>
                 <a:cs typeface="Arial" pitchFamily="34" charset="-120"/>
               </a:rPr>
@@ -9069,7 +9069,7 @@
                 <a:solidFill>
                   <a:srgbClr val="FFFFFF"/>
                 </a:solidFill>
-                <a:latin typeface="Poppins" pitchFamily="34" charset="0"/>
+                <a:latin typeface="DM Sans 14pt" pitchFamily="34" charset="0"/>
                 <a:ea typeface="Arial" pitchFamily="34" charset="-122"/>
                 <a:cs typeface="Arial" pitchFamily="34" charset="-120"/>
               </a:rPr>
@@ -9230,7 +9230,7 @@
                 <a:solidFill>
                   <a:srgbClr val="FFFFFF"/>
                 </a:solidFill>
-                <a:latin typeface="Poppins" pitchFamily="34" charset="0"/>
+                <a:latin typeface="Playfair Display" pitchFamily="34" charset="0"/>
                 <a:ea typeface="Arial" pitchFamily="34" charset="-122"/>
                 <a:cs typeface="Arial" pitchFamily="34" charset="-120"/>
               </a:rPr>
@@ -9269,7 +9269,7 @@
                 <a:solidFill>
                   <a:srgbClr val="FFFFFF"/>
                 </a:solidFill>
-                <a:latin typeface="Poppins" pitchFamily="34" charset="0"/>
+                <a:latin typeface="DM Sans 14pt" pitchFamily="34" charset="0"/>
                 <a:ea typeface="Arial" pitchFamily="34" charset="-122"/>
                 <a:cs typeface="Arial" pitchFamily="34" charset="-120"/>
               </a:rPr>
@@ -9304,70 +9304,70 @@
               <a:buNone/>
             </a:pPr>
             <a:r>
-              <a:rPr lang="en-US" sz="850" b="1" dirty="0">
+              <a:rPr lang="en-US" sz="850" b="1" dirty="0" spc="60">
                 <a:solidFill>
                   <a:srgbClr val="FFFFFF"/>
                 </a:solidFill>
-                <a:latin typeface="Poppins" pitchFamily="34" charset="0"/>
-                <a:ea typeface="Arial" pitchFamily="34" charset="-122"/>
-                <a:cs typeface="Arial" pitchFamily="34" charset="-120"/>
-              </a:rPr>
-              <a:t>MAN MOTORS S.A.  •  </a:t>
-            </a:r>
-            <a:r>
-              <a:rPr lang="en-US" sz="850" b="1" dirty="0" err="1">
+                <a:latin typeface="DM Sans 14pt" pitchFamily="34" charset="0"/>
+                <a:ea typeface="Arial" pitchFamily="34" charset="-122"/>
+                <a:cs typeface="Arial" pitchFamily="34" charset="-120"/>
+              </a:rPr>
+              <a:t>VENDAS DE ALTA PERFORMANCE  •  O CÓDIGO DAS VENDAS INFALÍVEIS</a:t>
+            </a:r>
+            <a:r>
+              <a:rPr lang="en-US" sz="850" b="1" dirty="0" err="1" spc="60">
                 <a:solidFill>
                   <a:srgbClr val="FFFFFF"/>
                 </a:solidFill>
-                <a:latin typeface="Poppins" pitchFamily="34" charset="0"/>
-                <a:ea typeface="Arial" pitchFamily="34" charset="-122"/>
-                <a:cs typeface="Arial" pitchFamily="34" charset="-120"/>
-              </a:rPr>
-              <a:t>Fuerza</a:t>
-            </a:r>
-            <a:r>
-              <a:rPr lang="en-US" sz="850" b="1" dirty="0">
+                <a:latin typeface="DM Sans 14pt" pitchFamily="34" charset="0"/>
+                <a:ea typeface="Arial" pitchFamily="34" charset="-122"/>
+                <a:cs typeface="Arial" pitchFamily="34" charset="-120"/>
+              </a:rPr>
+              <a:t/>
+            </a:r>
+            <a:r>
+              <a:rPr lang="en-US" sz="850" b="1" dirty="0" spc="60">
                 <a:solidFill>
                   <a:srgbClr val="FFFFFF"/>
                 </a:solidFill>
-                <a:latin typeface="Poppins" pitchFamily="34" charset="0"/>
-                <a:ea typeface="Arial" pitchFamily="34" charset="-122"/>
-                <a:cs typeface="Arial" pitchFamily="34" charset="-120"/>
-              </a:rPr>
-              <a:t> que </a:t>
-            </a:r>
-            <a:r>
-              <a:rPr lang="en-US" sz="850" b="1" dirty="0" err="1">
+                <a:latin typeface="DM Sans 14pt" pitchFamily="34" charset="0"/>
+                <a:ea typeface="Arial" pitchFamily="34" charset="-122"/>
+                <a:cs typeface="Arial" pitchFamily="34" charset="-120"/>
+              </a:rPr>
+              <a:t/>
+            </a:r>
+            <a:r>
+              <a:rPr lang="en-US" sz="850" b="1" dirty="0" err="1" spc="60">
                 <a:solidFill>
                   <a:srgbClr val="FFFFFF"/>
                 </a:solidFill>
-                <a:latin typeface="Poppins" pitchFamily="34" charset="0"/>
-                <a:ea typeface="Arial" pitchFamily="34" charset="-122"/>
-                <a:cs typeface="Arial" pitchFamily="34" charset="-120"/>
-              </a:rPr>
-              <a:t>conecta</a:t>
-            </a:r>
-            <a:r>
-              <a:rPr lang="en-US" sz="850" b="1" dirty="0">
+                <a:latin typeface="DM Sans 14pt" pitchFamily="34" charset="0"/>
+                <a:ea typeface="Arial" pitchFamily="34" charset="-122"/>
+                <a:cs typeface="Arial" pitchFamily="34" charset="-120"/>
+              </a:rPr>
+              <a:t/>
+            </a:r>
+            <a:r>
+              <a:rPr lang="en-US" sz="850" b="1" dirty="0" spc="60">
                 <a:solidFill>
                   <a:srgbClr val="FFFFFF"/>
                 </a:solidFill>
-                <a:latin typeface="Poppins" pitchFamily="34" charset="0"/>
-                <a:ea typeface="Arial" pitchFamily="34" charset="-122"/>
-                <a:cs typeface="Arial" pitchFamily="34" charset="-120"/>
-              </a:rPr>
-              <a:t> </a:t>
-            </a:r>
-            <a:r>
-              <a:rPr lang="en-US" sz="850" b="1" dirty="0" err="1">
+                <a:latin typeface="DM Sans 14pt" pitchFamily="34" charset="0"/>
+                <a:ea typeface="Arial" pitchFamily="34" charset="-122"/>
+                <a:cs typeface="Arial" pitchFamily="34" charset="-120"/>
+              </a:rPr>
+              <a:t/>
+            </a:r>
+            <a:r>
+              <a:rPr lang="en-US" sz="850" b="1" dirty="0" err="1" spc="60">
                 <a:solidFill>
                   <a:srgbClr val="FFFFFF"/>
                 </a:solidFill>
-                <a:latin typeface="Poppins" pitchFamily="34" charset="0"/>
-                <a:ea typeface="Arial" pitchFamily="34" charset="-122"/>
-                <a:cs typeface="Arial" pitchFamily="34" charset="-120"/>
-              </a:rPr>
-              <a:t>caminos</a:t>
+                <a:latin typeface="DM Sans 14pt" pitchFamily="34" charset="0"/>
+                <a:ea typeface="Arial" pitchFamily="34" charset="-122"/>
+                <a:cs typeface="Arial" pitchFamily="34" charset="-120"/>
+              </a:rPr>
+              <a:t/>
             </a:r>
             <a:endParaRPr lang="en-US" sz="850" dirty="0"/>
           </a:p>
@@ -9398,11 +9398,11 @@
               <a:buNone/>
             </a:pPr>
             <a:r>
-              <a:rPr lang="en-US" sz="850" dirty="0">
+              <a:rPr lang="en-US" sz="850" dirty="0" spc="60">
                 <a:solidFill>
                   <a:srgbClr val="FFFFFF"/>
                 </a:solidFill>
-                <a:latin typeface="Poppins" pitchFamily="34" charset="0"/>
+                <a:latin typeface="DM Sans 14pt" pitchFamily="34" charset="0"/>
                 <a:ea typeface="Arial" pitchFamily="34" charset="-122"/>
                 <a:cs typeface="Arial" pitchFamily="34" charset="-120"/>
               </a:rPr>
@@ -9499,7 +9499,7 @@
                 <a:solidFill>
                   <a:srgbClr val="151210"/>
                 </a:solidFill>
-                <a:latin typeface="Poppins" pitchFamily="34" charset="0"/>
+                <a:latin typeface="Playfair Display" pitchFamily="34" charset="0"/>
                 <a:ea typeface="Arial" pitchFamily="34" charset="-122"/>
                 <a:cs typeface="Arial" pitchFamily="34" charset="-120"/>
               </a:rPr>
@@ -9538,7 +9538,7 @@
                 <a:solidFill>
                   <a:srgbClr val="C08A2A"/>
                 </a:solidFill>
-                <a:latin typeface="Poppins" pitchFamily="34" charset="0"/>
+                <a:latin typeface="DM Sans 14pt" pitchFamily="34" charset="0"/>
                 <a:ea typeface="Arial" pitchFamily="34" charset="-122"/>
                 <a:cs typeface="Arial" pitchFamily="34" charset="-120"/>
               </a:rPr>
@@ -9579,7 +9579,7 @@
                 <a:solidFill>
                   <a:srgbClr val="151210"/>
                 </a:solidFill>
-                <a:latin typeface="Poppins" pitchFamily="34" charset="0"/>
+                <a:latin typeface="Playfair Display" pitchFamily="34" charset="0"/>
                 <a:ea typeface="Arial" pitchFamily="34" charset="-122"/>
                 <a:cs typeface="Arial" pitchFamily="34" charset="-120"/>
               </a:rPr>
@@ -9620,7 +9620,7 @@
                 <a:solidFill>
                   <a:srgbClr val="151210"/>
                 </a:solidFill>
-                <a:latin typeface="Poppins" pitchFamily="34" charset="0"/>
+                <a:latin typeface="DM Sans 14pt" pitchFamily="34" charset="0"/>
                 <a:ea typeface="Arial" pitchFamily="34" charset="-122"/>
                 <a:cs typeface="Arial" pitchFamily="34" charset="-120"/>
               </a:rPr>
@@ -9686,7 +9686,7 @@
                 <a:solidFill>
                   <a:srgbClr val="96651A"/>
                 </a:solidFill>
-                <a:latin typeface="Poppins" pitchFamily="34" charset="0"/>
+                <a:latin typeface="Playfair Display" pitchFamily="34" charset="0"/>
                 <a:ea typeface="Arial" pitchFamily="34" charset="-122"/>
                 <a:cs typeface="Arial" pitchFamily="34" charset="-120"/>
               </a:rPr>
@@ -9727,7 +9727,7 @@
                 <a:solidFill>
                   <a:srgbClr val="151210"/>
                 </a:solidFill>
-                <a:latin typeface="Poppins" pitchFamily="34" charset="0"/>
+                <a:latin typeface="DM Sans 14pt" pitchFamily="34" charset="0"/>
                 <a:ea typeface="Arial" pitchFamily="34" charset="-122"/>
                 <a:cs typeface="Arial" pitchFamily="34" charset="-120"/>
               </a:rPr>
@@ -9744,7 +9744,7 @@
                 <a:solidFill>
                   <a:srgbClr val="151210"/>
                 </a:solidFill>
-                <a:latin typeface="Poppins" pitchFamily="34" charset="0"/>
+                <a:latin typeface="DM Sans 14pt" pitchFamily="34" charset="0"/>
                 <a:ea typeface="Arial" pitchFamily="34" charset="-122"/>
                 <a:cs typeface="Arial" pitchFamily="34" charset="-120"/>
               </a:rPr>
@@ -9761,7 +9761,7 @@
                 <a:solidFill>
                   <a:srgbClr val="151210"/>
                 </a:solidFill>
-                <a:latin typeface="Poppins" pitchFamily="34" charset="0"/>
+                <a:latin typeface="DM Sans 14pt" pitchFamily="34" charset="0"/>
                 <a:ea typeface="Arial" pitchFamily="34" charset="-122"/>
                 <a:cs typeface="Arial" pitchFamily="34" charset="-120"/>
               </a:rPr>
@@ -9778,7 +9778,7 @@
                 <a:solidFill>
                   <a:srgbClr val="151210"/>
                 </a:solidFill>
-                <a:latin typeface="Poppins" pitchFamily="34" charset="0"/>
+                <a:latin typeface="DM Sans 14pt" pitchFamily="34" charset="0"/>
                 <a:ea typeface="Arial" pitchFamily="34" charset="-122"/>
                 <a:cs typeface="Arial" pitchFamily="34" charset="-120"/>
               </a:rPr>
@@ -9846,7 +9846,7 @@
                 <a:solidFill>
                   <a:srgbClr val="151210"/>
                 </a:solidFill>
-                <a:latin typeface="Poppins" pitchFamily="34" charset="0"/>
+                <a:latin typeface="Playfair Display" pitchFamily="34" charset="0"/>
                 <a:ea typeface="Arial" pitchFamily="34" charset="-122"/>
                 <a:cs typeface="Arial" pitchFamily="34" charset="-120"/>
               </a:rPr>
@@ -9887,7 +9887,7 @@
                 <a:solidFill>
                   <a:srgbClr val="96651A"/>
                 </a:solidFill>
-                <a:latin typeface="Poppins" pitchFamily="34" charset="0"/>
+                <a:latin typeface="Playfair Display" pitchFamily="34" charset="0"/>
                 <a:ea typeface="Arial" pitchFamily="34" charset="-122"/>
                 <a:cs typeface="Arial" pitchFamily="34" charset="-120"/>
               </a:rPr>
@@ -9951,11 +9951,11 @@
               <a:buNone/>
             </a:pPr>
             <a:r>
-              <a:rPr lang="en-US" sz="1000" b="1" dirty="0">
+              <a:rPr lang="en-US" sz="1000" b="1" dirty="0" spc="60">
                 <a:solidFill>
                   <a:srgbClr val="E6BD5E"/>
                 </a:solidFill>
-                <a:latin typeface="Poppins" pitchFamily="34" charset="0"/>
+                <a:latin typeface="DM Sans 14pt" pitchFamily="34" charset="0"/>
                 <a:ea typeface="Arial" pitchFamily="34" charset="-122"/>
                 <a:cs typeface="Arial" pitchFamily="34" charset="-120"/>
               </a:rPr>
@@ -9996,7 +9996,7 @@
                 <a:solidFill>
                   <a:srgbClr val="FFFFFF"/>
                 </a:solidFill>
-                <a:latin typeface="Poppins" pitchFamily="34" charset="0"/>
+                <a:latin typeface="DM Sans 14pt" pitchFamily="34" charset="0"/>
                 <a:ea typeface="Arial" pitchFamily="34" charset="-122"/>
                 <a:cs typeface="Arial" pitchFamily="34" charset="-120"/>
               </a:rPr>
@@ -10157,7 +10157,7 @@
                 <a:solidFill>
                   <a:srgbClr val="FFFFFF"/>
                 </a:solidFill>
-                <a:latin typeface="Poppins" pitchFamily="34" charset="0"/>
+                <a:latin typeface="Playfair Display" pitchFamily="34" charset="0"/>
                 <a:ea typeface="Arial" pitchFamily="34" charset="-122"/>
                 <a:cs typeface="Arial" pitchFamily="34" charset="-120"/>
               </a:rPr>
@@ -10196,7 +10196,7 @@
                 <a:solidFill>
                   <a:srgbClr val="FFFFFF"/>
                 </a:solidFill>
-                <a:latin typeface="Poppins" pitchFamily="34" charset="0"/>
+                <a:latin typeface="DM Sans 14pt" pitchFamily="34" charset="0"/>
                 <a:ea typeface="Arial" pitchFamily="34" charset="-122"/>
                 <a:cs typeface="Arial" pitchFamily="34" charset="-120"/>
               </a:rPr>
@@ -10231,70 +10231,70 @@
               <a:buNone/>
             </a:pPr>
             <a:r>
-              <a:rPr lang="en-US" sz="850" b="1" dirty="0">
+              <a:rPr lang="en-US" sz="850" b="1" dirty="0" spc="60">
                 <a:solidFill>
                   <a:srgbClr val="FFFFFF"/>
                 </a:solidFill>
-                <a:latin typeface="Poppins" pitchFamily="34" charset="0"/>
-                <a:ea typeface="Arial" pitchFamily="34" charset="-122"/>
-                <a:cs typeface="Arial" pitchFamily="34" charset="-120"/>
-              </a:rPr>
-              <a:t>MAN MOTORS S.A.  •  </a:t>
-            </a:r>
-            <a:r>
-              <a:rPr lang="en-US" sz="850" b="1" dirty="0" err="1">
+                <a:latin typeface="DM Sans 14pt" pitchFamily="34" charset="0"/>
+                <a:ea typeface="Arial" pitchFamily="34" charset="-122"/>
+                <a:cs typeface="Arial" pitchFamily="34" charset="-120"/>
+              </a:rPr>
+              <a:t>VENDAS DE ALTA PERFORMANCE  •  O CÓDIGO DAS VENDAS INFALÍVEIS</a:t>
+            </a:r>
+            <a:r>
+              <a:rPr lang="en-US" sz="850" b="1" dirty="0" err="1" spc="60">
                 <a:solidFill>
                   <a:srgbClr val="FFFFFF"/>
                 </a:solidFill>
-                <a:latin typeface="Poppins" pitchFamily="34" charset="0"/>
-                <a:ea typeface="Arial" pitchFamily="34" charset="-122"/>
-                <a:cs typeface="Arial" pitchFamily="34" charset="-120"/>
-              </a:rPr>
-              <a:t>Fuerza</a:t>
-            </a:r>
-            <a:r>
-              <a:rPr lang="en-US" sz="850" b="1" dirty="0">
+                <a:latin typeface="DM Sans 14pt" pitchFamily="34" charset="0"/>
+                <a:ea typeface="Arial" pitchFamily="34" charset="-122"/>
+                <a:cs typeface="Arial" pitchFamily="34" charset="-120"/>
+              </a:rPr>
+              <a:t/>
+            </a:r>
+            <a:r>
+              <a:rPr lang="en-US" sz="850" b="1" dirty="0" spc="60">
                 <a:solidFill>
                   <a:srgbClr val="FFFFFF"/>
                 </a:solidFill>
-                <a:latin typeface="Poppins" pitchFamily="34" charset="0"/>
-                <a:ea typeface="Arial" pitchFamily="34" charset="-122"/>
-                <a:cs typeface="Arial" pitchFamily="34" charset="-120"/>
-              </a:rPr>
-              <a:t> que </a:t>
-            </a:r>
-            <a:r>
-              <a:rPr lang="en-US" sz="850" b="1" dirty="0" err="1">
+                <a:latin typeface="DM Sans 14pt" pitchFamily="34" charset="0"/>
+                <a:ea typeface="Arial" pitchFamily="34" charset="-122"/>
+                <a:cs typeface="Arial" pitchFamily="34" charset="-120"/>
+              </a:rPr>
+              <a:t/>
+            </a:r>
+            <a:r>
+              <a:rPr lang="en-US" sz="850" b="1" dirty="0" err="1" spc="60">
                 <a:solidFill>
                   <a:srgbClr val="FFFFFF"/>
                 </a:solidFill>
-                <a:latin typeface="Poppins" pitchFamily="34" charset="0"/>
-                <a:ea typeface="Arial" pitchFamily="34" charset="-122"/>
-                <a:cs typeface="Arial" pitchFamily="34" charset="-120"/>
-              </a:rPr>
-              <a:t>conecta</a:t>
-            </a:r>
-            <a:r>
-              <a:rPr lang="en-US" sz="850" b="1" dirty="0">
+                <a:latin typeface="DM Sans 14pt" pitchFamily="34" charset="0"/>
+                <a:ea typeface="Arial" pitchFamily="34" charset="-122"/>
+                <a:cs typeface="Arial" pitchFamily="34" charset="-120"/>
+              </a:rPr>
+              <a:t/>
+            </a:r>
+            <a:r>
+              <a:rPr lang="en-US" sz="850" b="1" dirty="0" spc="60">
                 <a:solidFill>
                   <a:srgbClr val="FFFFFF"/>
                 </a:solidFill>
-                <a:latin typeface="Poppins" pitchFamily="34" charset="0"/>
-                <a:ea typeface="Arial" pitchFamily="34" charset="-122"/>
-                <a:cs typeface="Arial" pitchFamily="34" charset="-120"/>
-              </a:rPr>
-              <a:t> </a:t>
-            </a:r>
-            <a:r>
-              <a:rPr lang="en-US" sz="850" b="1" dirty="0" err="1">
+                <a:latin typeface="DM Sans 14pt" pitchFamily="34" charset="0"/>
+                <a:ea typeface="Arial" pitchFamily="34" charset="-122"/>
+                <a:cs typeface="Arial" pitchFamily="34" charset="-120"/>
+              </a:rPr>
+              <a:t/>
+            </a:r>
+            <a:r>
+              <a:rPr lang="en-US" sz="850" b="1" dirty="0" err="1" spc="60">
                 <a:solidFill>
                   <a:srgbClr val="FFFFFF"/>
                 </a:solidFill>
-                <a:latin typeface="Poppins" pitchFamily="34" charset="0"/>
-                <a:ea typeface="Arial" pitchFamily="34" charset="-122"/>
-                <a:cs typeface="Arial" pitchFamily="34" charset="-120"/>
-              </a:rPr>
-              <a:t>caminos</a:t>
+                <a:latin typeface="DM Sans 14pt" pitchFamily="34" charset="0"/>
+                <a:ea typeface="Arial" pitchFamily="34" charset="-122"/>
+                <a:cs typeface="Arial" pitchFamily="34" charset="-120"/>
+              </a:rPr>
+              <a:t/>
             </a:r>
             <a:endParaRPr lang="en-US" sz="850" dirty="0"/>
           </a:p>
@@ -10325,11 +10325,11 @@
               <a:buNone/>
             </a:pPr>
             <a:r>
-              <a:rPr lang="en-US" sz="850" dirty="0">
+              <a:rPr lang="en-US" sz="850" dirty="0" spc="60">
                 <a:solidFill>
                   <a:srgbClr val="FFFFFF"/>
                 </a:solidFill>
-                <a:latin typeface="Poppins" pitchFamily="34" charset="0"/>
+                <a:latin typeface="DM Sans 14pt" pitchFamily="34" charset="0"/>
                 <a:ea typeface="Arial" pitchFamily="34" charset="-122"/>
                 <a:cs typeface="Arial" pitchFamily="34" charset="-120"/>
               </a:rPr>
@@ -10426,7 +10426,7 @@
                 <a:solidFill>
                   <a:srgbClr val="151210"/>
                 </a:solidFill>
-                <a:latin typeface="Poppins" pitchFamily="34" charset="0"/>
+                <a:latin typeface="Playfair Display" pitchFamily="34" charset="0"/>
                 <a:ea typeface="Arial" pitchFamily="34" charset="-122"/>
                 <a:cs typeface="Arial" pitchFamily="34" charset="-120"/>
               </a:rPr>
@@ -10465,7 +10465,7 @@
                 <a:solidFill>
                   <a:srgbClr val="C08A2A"/>
                 </a:solidFill>
-                <a:latin typeface="Poppins" pitchFamily="34" charset="0"/>
+                <a:latin typeface="DM Sans 14pt" pitchFamily="34" charset="0"/>
                 <a:ea typeface="Arial" pitchFamily="34" charset="-122"/>
                 <a:cs typeface="Arial" pitchFamily="34" charset="-120"/>
               </a:rPr>
@@ -10506,7 +10506,7 @@
                 <a:solidFill>
                   <a:srgbClr val="151210"/>
                 </a:solidFill>
-                <a:latin typeface="Poppins" pitchFamily="34" charset="0"/>
+                <a:latin typeface="Playfair Display" pitchFamily="34" charset="0"/>
                 <a:ea typeface="Arial" pitchFamily="34" charset="-122"/>
                 <a:cs typeface="Arial" pitchFamily="34" charset="-120"/>
               </a:rPr>
@@ -10547,7 +10547,7 @@
                 <a:solidFill>
                   <a:srgbClr val="151210"/>
                 </a:solidFill>
-                <a:latin typeface="Poppins" pitchFamily="34" charset="0"/>
+                <a:latin typeface="DM Sans 14pt" pitchFamily="34" charset="0"/>
                 <a:ea typeface="Arial" pitchFamily="34" charset="-122"/>
                 <a:cs typeface="Arial" pitchFamily="34" charset="-120"/>
               </a:rPr>
@@ -10613,7 +10613,7 @@
                 <a:solidFill>
                   <a:srgbClr val="96651A"/>
                 </a:solidFill>
-                <a:latin typeface="Poppins" pitchFamily="34" charset="0"/>
+                <a:latin typeface="Playfair Display" pitchFamily="34" charset="0"/>
                 <a:ea typeface="Arial" pitchFamily="34" charset="-122"/>
                 <a:cs typeface="Arial" pitchFamily="34" charset="-120"/>
               </a:rPr>
@@ -10654,7 +10654,7 @@
                 <a:solidFill>
                   <a:srgbClr val="151210"/>
                 </a:solidFill>
-                <a:latin typeface="Poppins" pitchFamily="34" charset="0"/>
+                <a:latin typeface="DM Sans 14pt" pitchFamily="34" charset="0"/>
                 <a:ea typeface="Arial" pitchFamily="34" charset="-122"/>
                 <a:cs typeface="Arial" pitchFamily="34" charset="-120"/>
               </a:rPr>
@@ -10671,7 +10671,7 @@
                 <a:solidFill>
                   <a:srgbClr val="151210"/>
                 </a:solidFill>
-                <a:latin typeface="Poppins" pitchFamily="34" charset="0"/>
+                <a:latin typeface="DM Sans 14pt" pitchFamily="34" charset="0"/>
                 <a:ea typeface="Arial" pitchFamily="34" charset="-122"/>
                 <a:cs typeface="Arial" pitchFamily="34" charset="-120"/>
               </a:rPr>
@@ -10688,7 +10688,7 @@
                 <a:solidFill>
                   <a:srgbClr val="151210"/>
                 </a:solidFill>
-                <a:latin typeface="Poppins" pitchFamily="34" charset="0"/>
+                <a:latin typeface="DM Sans 14pt" pitchFamily="34" charset="0"/>
                 <a:ea typeface="Arial" pitchFamily="34" charset="-122"/>
                 <a:cs typeface="Arial" pitchFamily="34" charset="-120"/>
               </a:rPr>
@@ -10756,7 +10756,7 @@
                 <a:solidFill>
                   <a:srgbClr val="151210"/>
                 </a:solidFill>
-                <a:latin typeface="Poppins" pitchFamily="34" charset="0"/>
+                <a:latin typeface="Playfair Display" pitchFamily="34" charset="0"/>
                 <a:ea typeface="Arial" pitchFamily="34" charset="-122"/>
                 <a:cs typeface="Arial" pitchFamily="34" charset="-120"/>
               </a:rPr>
@@ -10797,7 +10797,7 @@
                 <a:solidFill>
                   <a:srgbClr val="96651A"/>
                 </a:solidFill>
-                <a:latin typeface="Poppins" pitchFamily="34" charset="0"/>
+                <a:latin typeface="Playfair Display" pitchFamily="34" charset="0"/>
                 <a:ea typeface="Arial" pitchFamily="34" charset="-122"/>
                 <a:cs typeface="Arial" pitchFamily="34" charset="-120"/>
               </a:rPr>
@@ -10861,11 +10861,11 @@
               <a:buNone/>
             </a:pPr>
             <a:r>
-              <a:rPr lang="en-US" sz="1000" b="1" dirty="0">
+              <a:rPr lang="en-US" sz="1000" b="1" dirty="0" spc="60">
                 <a:solidFill>
                   <a:srgbClr val="E6BD5E"/>
                 </a:solidFill>
-                <a:latin typeface="Poppins" pitchFamily="34" charset="0"/>
+                <a:latin typeface="DM Sans 14pt" pitchFamily="34" charset="0"/>
                 <a:ea typeface="Arial" pitchFamily="34" charset="-122"/>
                 <a:cs typeface="Arial" pitchFamily="34" charset="-120"/>
               </a:rPr>
@@ -10906,7 +10906,7 @@
                 <a:solidFill>
                   <a:srgbClr val="FFFFFF"/>
                 </a:solidFill>
-                <a:latin typeface="Poppins" pitchFamily="34" charset="0"/>
+                <a:latin typeface="DM Sans 14pt" pitchFamily="34" charset="0"/>
                 <a:ea typeface="Arial" pitchFamily="34" charset="-122"/>
                 <a:cs typeface="Arial" pitchFamily="34" charset="-120"/>
               </a:rPr>
@@ -11067,7 +11067,7 @@
                 <a:solidFill>
                   <a:srgbClr val="FFFFFF"/>
                 </a:solidFill>
-                <a:latin typeface="Poppins" pitchFamily="34" charset="0"/>
+                <a:latin typeface="Playfair Display" pitchFamily="34" charset="0"/>
                 <a:ea typeface="Arial" pitchFamily="34" charset="-122"/>
                 <a:cs typeface="Arial" pitchFamily="34" charset="-120"/>
               </a:rPr>
@@ -11106,7 +11106,7 @@
                 <a:solidFill>
                   <a:srgbClr val="FFFFFF"/>
                 </a:solidFill>
-                <a:latin typeface="Poppins" pitchFamily="34" charset="0"/>
+                <a:latin typeface="DM Sans 14pt" pitchFamily="34" charset="0"/>
                 <a:ea typeface="Arial" pitchFamily="34" charset="-122"/>
                 <a:cs typeface="Arial" pitchFamily="34" charset="-120"/>
               </a:rPr>
@@ -11141,70 +11141,70 @@
               <a:buNone/>
             </a:pPr>
             <a:r>
-              <a:rPr lang="en-US" sz="850" b="1" dirty="0">
+              <a:rPr lang="en-US" sz="850" b="1" dirty="0" spc="60">
                 <a:solidFill>
                   <a:srgbClr val="FFFFFF"/>
                 </a:solidFill>
-                <a:latin typeface="Poppins" pitchFamily="34" charset="0"/>
-                <a:ea typeface="Arial" pitchFamily="34" charset="-122"/>
-                <a:cs typeface="Arial" pitchFamily="34" charset="-120"/>
-              </a:rPr>
-              <a:t>MAN MOTORS S.A.  •  </a:t>
-            </a:r>
-            <a:r>
-              <a:rPr lang="en-US" sz="850" b="1" dirty="0" err="1">
+                <a:latin typeface="DM Sans 14pt" pitchFamily="34" charset="0"/>
+                <a:ea typeface="Arial" pitchFamily="34" charset="-122"/>
+                <a:cs typeface="Arial" pitchFamily="34" charset="-120"/>
+              </a:rPr>
+              <a:t>VENDAS DE ALTA PERFORMANCE  •  O CÓDIGO DAS VENDAS INFALÍVEIS</a:t>
+            </a:r>
+            <a:r>
+              <a:rPr lang="en-US" sz="850" b="1" dirty="0" err="1" spc="60">
                 <a:solidFill>
                   <a:srgbClr val="FFFFFF"/>
                 </a:solidFill>
-                <a:latin typeface="Poppins" pitchFamily="34" charset="0"/>
-                <a:ea typeface="Arial" pitchFamily="34" charset="-122"/>
-                <a:cs typeface="Arial" pitchFamily="34" charset="-120"/>
-              </a:rPr>
-              <a:t>Fuerza</a:t>
-            </a:r>
-            <a:r>
-              <a:rPr lang="en-US" sz="850" b="1" dirty="0">
+                <a:latin typeface="DM Sans 14pt" pitchFamily="34" charset="0"/>
+                <a:ea typeface="Arial" pitchFamily="34" charset="-122"/>
+                <a:cs typeface="Arial" pitchFamily="34" charset="-120"/>
+              </a:rPr>
+              <a:t/>
+            </a:r>
+            <a:r>
+              <a:rPr lang="en-US" sz="850" b="1" dirty="0" spc="60">
                 <a:solidFill>
                   <a:srgbClr val="FFFFFF"/>
                 </a:solidFill>
-                <a:latin typeface="Poppins" pitchFamily="34" charset="0"/>
-                <a:ea typeface="Arial" pitchFamily="34" charset="-122"/>
-                <a:cs typeface="Arial" pitchFamily="34" charset="-120"/>
-              </a:rPr>
-              <a:t> que </a:t>
-            </a:r>
-            <a:r>
-              <a:rPr lang="en-US" sz="850" b="1" dirty="0" err="1">
+                <a:latin typeface="DM Sans 14pt" pitchFamily="34" charset="0"/>
+                <a:ea typeface="Arial" pitchFamily="34" charset="-122"/>
+                <a:cs typeface="Arial" pitchFamily="34" charset="-120"/>
+              </a:rPr>
+              <a:t/>
+            </a:r>
+            <a:r>
+              <a:rPr lang="en-US" sz="850" b="1" dirty="0" err="1" spc="60">
                 <a:solidFill>
                   <a:srgbClr val="FFFFFF"/>
                 </a:solidFill>
-                <a:latin typeface="Poppins" pitchFamily="34" charset="0"/>
-                <a:ea typeface="Arial" pitchFamily="34" charset="-122"/>
-                <a:cs typeface="Arial" pitchFamily="34" charset="-120"/>
-              </a:rPr>
-              <a:t>conecta</a:t>
-            </a:r>
-            <a:r>
-              <a:rPr lang="en-US" sz="850" b="1" dirty="0">
+                <a:latin typeface="DM Sans 14pt" pitchFamily="34" charset="0"/>
+                <a:ea typeface="Arial" pitchFamily="34" charset="-122"/>
+                <a:cs typeface="Arial" pitchFamily="34" charset="-120"/>
+              </a:rPr>
+              <a:t/>
+            </a:r>
+            <a:r>
+              <a:rPr lang="en-US" sz="850" b="1" dirty="0" spc="60">
                 <a:solidFill>
                   <a:srgbClr val="FFFFFF"/>
                 </a:solidFill>
-                <a:latin typeface="Poppins" pitchFamily="34" charset="0"/>
-                <a:ea typeface="Arial" pitchFamily="34" charset="-122"/>
-                <a:cs typeface="Arial" pitchFamily="34" charset="-120"/>
-              </a:rPr>
-              <a:t> </a:t>
-            </a:r>
-            <a:r>
-              <a:rPr lang="en-US" sz="850" b="1" dirty="0" err="1">
+                <a:latin typeface="DM Sans 14pt" pitchFamily="34" charset="0"/>
+                <a:ea typeface="Arial" pitchFamily="34" charset="-122"/>
+                <a:cs typeface="Arial" pitchFamily="34" charset="-120"/>
+              </a:rPr>
+              <a:t/>
+            </a:r>
+            <a:r>
+              <a:rPr lang="en-US" sz="850" b="1" dirty="0" err="1" spc="60">
                 <a:solidFill>
                   <a:srgbClr val="FFFFFF"/>
                 </a:solidFill>
-                <a:latin typeface="Poppins" pitchFamily="34" charset="0"/>
-                <a:ea typeface="Arial" pitchFamily="34" charset="-122"/>
-                <a:cs typeface="Arial" pitchFamily="34" charset="-120"/>
-              </a:rPr>
-              <a:t>caminos</a:t>
+                <a:latin typeface="DM Sans 14pt" pitchFamily="34" charset="0"/>
+                <a:ea typeface="Arial" pitchFamily="34" charset="-122"/>
+                <a:cs typeface="Arial" pitchFamily="34" charset="-120"/>
+              </a:rPr>
+              <a:t/>
             </a:r>
             <a:endParaRPr lang="en-US" sz="850" dirty="0"/>
           </a:p>
@@ -11235,11 +11235,11 @@
               <a:buNone/>
             </a:pPr>
             <a:r>
-              <a:rPr lang="en-US" sz="850" dirty="0">
+              <a:rPr lang="en-US" sz="850" dirty="0" spc="60">
                 <a:solidFill>
                   <a:srgbClr val="FFFFFF"/>
                 </a:solidFill>
-                <a:latin typeface="Poppins" pitchFamily="34" charset="0"/>
+                <a:latin typeface="DM Sans 14pt" pitchFamily="34" charset="0"/>
                 <a:ea typeface="Arial" pitchFamily="34" charset="-122"/>
                 <a:cs typeface="Arial" pitchFamily="34" charset="-120"/>
               </a:rPr>
@@ -11336,7 +11336,7 @@
                 <a:solidFill>
                   <a:srgbClr val="151210"/>
                 </a:solidFill>
-                <a:latin typeface="Poppins" pitchFamily="34" charset="0"/>
+                <a:latin typeface="Playfair Display" pitchFamily="34" charset="0"/>
                 <a:ea typeface="Arial" pitchFamily="34" charset="-122"/>
                 <a:cs typeface="Arial" pitchFamily="34" charset="-120"/>
               </a:rPr>
@@ -11375,7 +11375,7 @@
                 <a:solidFill>
                   <a:srgbClr val="C08A2A"/>
                 </a:solidFill>
-                <a:latin typeface="Poppins" pitchFamily="34" charset="0"/>
+                <a:latin typeface="DM Sans 14pt" pitchFamily="34" charset="0"/>
                 <a:ea typeface="Arial" pitchFamily="34" charset="-122"/>
                 <a:cs typeface="Arial" pitchFamily="34" charset="-120"/>
               </a:rPr>
@@ -11416,7 +11416,7 @@
                 <a:solidFill>
                   <a:srgbClr val="151210"/>
                 </a:solidFill>
-                <a:latin typeface="Poppins" pitchFamily="34" charset="0"/>
+                <a:latin typeface="Playfair Display" pitchFamily="34" charset="0"/>
                 <a:ea typeface="Arial" pitchFamily="34" charset="-122"/>
                 <a:cs typeface="Arial" pitchFamily="34" charset="-120"/>
               </a:rPr>
@@ -11457,7 +11457,7 @@
                 <a:solidFill>
                   <a:srgbClr val="151210"/>
                 </a:solidFill>
-                <a:latin typeface="Poppins" pitchFamily="34" charset="0"/>
+                <a:latin typeface="DM Sans 14pt" pitchFamily="34" charset="0"/>
                 <a:ea typeface="Arial" pitchFamily="34" charset="-122"/>
                 <a:cs typeface="Arial" pitchFamily="34" charset="-120"/>
               </a:rPr>
@@ -11523,7 +11523,7 @@
                 <a:solidFill>
                   <a:srgbClr val="96651A"/>
                 </a:solidFill>
-                <a:latin typeface="Poppins" pitchFamily="34" charset="0"/>
+                <a:latin typeface="Playfair Display" pitchFamily="34" charset="0"/>
                 <a:ea typeface="Arial" pitchFamily="34" charset="-122"/>
                 <a:cs typeface="Arial" pitchFamily="34" charset="-120"/>
               </a:rPr>
@@ -11564,7 +11564,7 @@
                 <a:solidFill>
                   <a:srgbClr val="151210"/>
                 </a:solidFill>
-                <a:latin typeface="Poppins" pitchFamily="34" charset="0"/>
+                <a:latin typeface="DM Sans 14pt" pitchFamily="34" charset="0"/>
                 <a:ea typeface="Arial" pitchFamily="34" charset="-122"/>
                 <a:cs typeface="Arial" pitchFamily="34" charset="-120"/>
               </a:rPr>
@@ -11581,7 +11581,7 @@
                 <a:solidFill>
                   <a:srgbClr val="151210"/>
                 </a:solidFill>
-                <a:latin typeface="Poppins" pitchFamily="34" charset="0"/>
+                <a:latin typeface="DM Sans 14pt" pitchFamily="34" charset="0"/>
                 <a:ea typeface="Arial" pitchFamily="34" charset="-122"/>
                 <a:cs typeface="Arial" pitchFamily="34" charset="-120"/>
               </a:rPr>
@@ -11598,7 +11598,7 @@
                 <a:solidFill>
                   <a:srgbClr val="151210"/>
                 </a:solidFill>
-                <a:latin typeface="Poppins" pitchFamily="34" charset="0"/>
+                <a:latin typeface="DM Sans 14pt" pitchFamily="34" charset="0"/>
                 <a:ea typeface="Arial" pitchFamily="34" charset="-122"/>
                 <a:cs typeface="Arial" pitchFamily="34" charset="-120"/>
               </a:rPr>
@@ -11666,7 +11666,7 @@
                 <a:solidFill>
                   <a:srgbClr val="151210"/>
                 </a:solidFill>
-                <a:latin typeface="Poppins" pitchFamily="34" charset="0"/>
+                <a:latin typeface="Playfair Display" pitchFamily="34" charset="0"/>
                 <a:ea typeface="Arial" pitchFamily="34" charset="-122"/>
                 <a:cs typeface="Arial" pitchFamily="34" charset="-120"/>
               </a:rPr>
@@ -11707,7 +11707,7 @@
                 <a:solidFill>
                   <a:srgbClr val="96651A"/>
                 </a:solidFill>
-                <a:latin typeface="Poppins" pitchFamily="34" charset="0"/>
+                <a:latin typeface="Playfair Display" pitchFamily="34" charset="0"/>
                 <a:ea typeface="Arial" pitchFamily="34" charset="-122"/>
                 <a:cs typeface="Arial" pitchFamily="34" charset="-120"/>
               </a:rPr>
@@ -11771,11 +11771,11 @@
               <a:buNone/>
             </a:pPr>
             <a:r>
-              <a:rPr lang="en-US" sz="1000" b="1" dirty="0">
+              <a:rPr lang="en-US" sz="1000" b="1" dirty="0" spc="60">
                 <a:solidFill>
                   <a:srgbClr val="E6BD5E"/>
                 </a:solidFill>
-                <a:latin typeface="Poppins" pitchFamily="34" charset="0"/>
+                <a:latin typeface="DM Sans 14pt" pitchFamily="34" charset="0"/>
                 <a:ea typeface="Arial" pitchFamily="34" charset="-122"/>
                 <a:cs typeface="Arial" pitchFamily="34" charset="-120"/>
               </a:rPr>
@@ -11816,7 +11816,7 @@
                 <a:solidFill>
                   <a:srgbClr val="FFFFFF"/>
                 </a:solidFill>
-                <a:latin typeface="Poppins" pitchFamily="34" charset="0"/>
+                <a:latin typeface="DM Sans 14pt" pitchFamily="34" charset="0"/>
                 <a:ea typeface="Arial" pitchFamily="34" charset="-122"/>
                 <a:cs typeface="Arial" pitchFamily="34" charset="-120"/>
               </a:rPr>
@@ -11977,7 +11977,7 @@
                 <a:solidFill>
                   <a:srgbClr val="FFFFFF"/>
                 </a:solidFill>
-                <a:latin typeface="Poppins" pitchFamily="34" charset="0"/>
+                <a:latin typeface="Playfair Display" pitchFamily="34" charset="0"/>
                 <a:ea typeface="Arial" pitchFamily="34" charset="-122"/>
                 <a:cs typeface="Arial" pitchFamily="34" charset="-120"/>
               </a:rPr>
@@ -12016,7 +12016,7 @@
                 <a:solidFill>
                   <a:srgbClr val="FFFFFF"/>
                 </a:solidFill>
-                <a:latin typeface="Poppins" pitchFamily="34" charset="0"/>
+                <a:latin typeface="DM Sans 14pt" pitchFamily="34" charset="0"/>
                 <a:ea typeface="Arial" pitchFamily="34" charset="-122"/>
                 <a:cs typeface="Arial" pitchFamily="34" charset="-120"/>
               </a:rPr>
@@ -12051,70 +12051,70 @@
               <a:buNone/>
             </a:pPr>
             <a:r>
-              <a:rPr lang="en-US" sz="850" b="1" dirty="0">
+              <a:rPr lang="en-US" sz="850" b="1" dirty="0" spc="60">
                 <a:solidFill>
                   <a:srgbClr val="FFFFFF"/>
                 </a:solidFill>
-                <a:latin typeface="Poppins" pitchFamily="34" charset="0"/>
-                <a:ea typeface="Arial" pitchFamily="34" charset="-122"/>
-                <a:cs typeface="Arial" pitchFamily="34" charset="-120"/>
-              </a:rPr>
-              <a:t>MAN MOTORS S.A.  •  </a:t>
-            </a:r>
-            <a:r>
-              <a:rPr lang="en-US" sz="850" b="1" dirty="0" err="1">
+                <a:latin typeface="DM Sans 14pt" pitchFamily="34" charset="0"/>
+                <a:ea typeface="Arial" pitchFamily="34" charset="-122"/>
+                <a:cs typeface="Arial" pitchFamily="34" charset="-120"/>
+              </a:rPr>
+              <a:t>VENDAS DE ALTA PERFORMANCE  •  O CÓDIGO DAS VENDAS INFALÍVEIS</a:t>
+            </a:r>
+            <a:r>
+              <a:rPr lang="en-US" sz="850" b="1" dirty="0" err="1" spc="60">
                 <a:solidFill>
                   <a:srgbClr val="FFFFFF"/>
                 </a:solidFill>
-                <a:latin typeface="Poppins" pitchFamily="34" charset="0"/>
-                <a:ea typeface="Arial" pitchFamily="34" charset="-122"/>
-                <a:cs typeface="Arial" pitchFamily="34" charset="-120"/>
-              </a:rPr>
-              <a:t>Fuerza</a:t>
-            </a:r>
-            <a:r>
-              <a:rPr lang="en-US" sz="850" b="1" dirty="0">
+                <a:latin typeface="DM Sans 14pt" pitchFamily="34" charset="0"/>
+                <a:ea typeface="Arial" pitchFamily="34" charset="-122"/>
+                <a:cs typeface="Arial" pitchFamily="34" charset="-120"/>
+              </a:rPr>
+              <a:t/>
+            </a:r>
+            <a:r>
+              <a:rPr lang="en-US" sz="850" b="1" dirty="0" spc="60">
                 <a:solidFill>
                   <a:srgbClr val="FFFFFF"/>
                 </a:solidFill>
-                <a:latin typeface="Poppins" pitchFamily="34" charset="0"/>
-                <a:ea typeface="Arial" pitchFamily="34" charset="-122"/>
-                <a:cs typeface="Arial" pitchFamily="34" charset="-120"/>
-              </a:rPr>
-              <a:t> que </a:t>
-            </a:r>
-            <a:r>
-              <a:rPr lang="en-US" sz="850" b="1" dirty="0" err="1">
+                <a:latin typeface="DM Sans 14pt" pitchFamily="34" charset="0"/>
+                <a:ea typeface="Arial" pitchFamily="34" charset="-122"/>
+                <a:cs typeface="Arial" pitchFamily="34" charset="-120"/>
+              </a:rPr>
+              <a:t/>
+            </a:r>
+            <a:r>
+              <a:rPr lang="en-US" sz="850" b="1" dirty="0" err="1" spc="60">
                 <a:solidFill>
                   <a:srgbClr val="FFFFFF"/>
                 </a:solidFill>
-                <a:latin typeface="Poppins" pitchFamily="34" charset="0"/>
-                <a:ea typeface="Arial" pitchFamily="34" charset="-122"/>
-                <a:cs typeface="Arial" pitchFamily="34" charset="-120"/>
-              </a:rPr>
-              <a:t>conecta</a:t>
-            </a:r>
-            <a:r>
-              <a:rPr lang="en-US" sz="850" b="1" dirty="0">
+                <a:latin typeface="DM Sans 14pt" pitchFamily="34" charset="0"/>
+                <a:ea typeface="Arial" pitchFamily="34" charset="-122"/>
+                <a:cs typeface="Arial" pitchFamily="34" charset="-120"/>
+              </a:rPr>
+              <a:t/>
+            </a:r>
+            <a:r>
+              <a:rPr lang="en-US" sz="850" b="1" dirty="0" spc="60">
                 <a:solidFill>
                   <a:srgbClr val="FFFFFF"/>
                 </a:solidFill>
-                <a:latin typeface="Poppins" pitchFamily="34" charset="0"/>
-                <a:ea typeface="Arial" pitchFamily="34" charset="-122"/>
-                <a:cs typeface="Arial" pitchFamily="34" charset="-120"/>
-              </a:rPr>
-              <a:t> </a:t>
-            </a:r>
-            <a:r>
-              <a:rPr lang="en-US" sz="850" b="1" dirty="0" err="1">
+                <a:latin typeface="DM Sans 14pt" pitchFamily="34" charset="0"/>
+                <a:ea typeface="Arial" pitchFamily="34" charset="-122"/>
+                <a:cs typeface="Arial" pitchFamily="34" charset="-120"/>
+              </a:rPr>
+              <a:t/>
+            </a:r>
+            <a:r>
+              <a:rPr lang="en-US" sz="850" b="1" dirty="0" err="1" spc="60">
                 <a:solidFill>
                   <a:srgbClr val="FFFFFF"/>
                 </a:solidFill>
-                <a:latin typeface="Poppins" pitchFamily="34" charset="0"/>
-                <a:ea typeface="Arial" pitchFamily="34" charset="-122"/>
-                <a:cs typeface="Arial" pitchFamily="34" charset="-120"/>
-              </a:rPr>
-              <a:t>caminos</a:t>
+                <a:latin typeface="DM Sans 14pt" pitchFamily="34" charset="0"/>
+                <a:ea typeface="Arial" pitchFamily="34" charset="-122"/>
+                <a:cs typeface="Arial" pitchFamily="34" charset="-120"/>
+              </a:rPr>
+              <a:t/>
             </a:r>
             <a:endParaRPr lang="en-US" sz="850" dirty="0"/>
           </a:p>
@@ -12145,11 +12145,11 @@
               <a:buNone/>
             </a:pPr>
             <a:r>
-              <a:rPr lang="en-US" sz="850" dirty="0">
+              <a:rPr lang="en-US" sz="850" dirty="0" spc="60">
                 <a:solidFill>
                   <a:srgbClr val="FFFFFF"/>
                 </a:solidFill>
-                <a:latin typeface="Poppins" pitchFamily="34" charset="0"/>
+                <a:latin typeface="DM Sans 14pt" pitchFamily="34" charset="0"/>
                 <a:ea typeface="Arial" pitchFamily="34" charset="-122"/>
                 <a:cs typeface="Arial" pitchFamily="34" charset="-120"/>
               </a:rPr>
@@ -12246,7 +12246,7 @@
                 <a:solidFill>
                   <a:srgbClr val="151210"/>
                 </a:solidFill>
-                <a:latin typeface="Poppins" pitchFamily="34" charset="0"/>
+                <a:latin typeface="Playfair Display" pitchFamily="34" charset="0"/>
                 <a:ea typeface="Arial" pitchFamily="34" charset="-122"/>
                 <a:cs typeface="Arial" pitchFamily="34" charset="-120"/>
               </a:rPr>
@@ -12285,7 +12285,7 @@
                 <a:solidFill>
                   <a:srgbClr val="C08A2A"/>
                 </a:solidFill>
-                <a:latin typeface="Poppins" pitchFamily="34" charset="0"/>
+                <a:latin typeface="DM Sans 14pt" pitchFamily="34" charset="0"/>
                 <a:ea typeface="Arial" pitchFamily="34" charset="-122"/>
                 <a:cs typeface="Arial" pitchFamily="34" charset="-120"/>
               </a:rPr>
@@ -12326,7 +12326,7 @@
                 <a:solidFill>
                   <a:srgbClr val="151210"/>
                 </a:solidFill>
-                <a:latin typeface="Poppins" pitchFamily="34" charset="0"/>
+                <a:latin typeface="Playfair Display" pitchFamily="34" charset="0"/>
                 <a:ea typeface="Arial" pitchFamily="34" charset="-122"/>
                 <a:cs typeface="Arial" pitchFamily="34" charset="-120"/>
               </a:rPr>
@@ -12367,7 +12367,7 @@
                 <a:solidFill>
                   <a:srgbClr val="151210"/>
                 </a:solidFill>
-                <a:latin typeface="Poppins" pitchFamily="34" charset="0"/>
+                <a:latin typeface="DM Sans 14pt" pitchFamily="34" charset="0"/>
                 <a:ea typeface="Arial" pitchFamily="34" charset="-122"/>
                 <a:cs typeface="Arial" pitchFamily="34" charset="-120"/>
               </a:rPr>
@@ -12433,7 +12433,7 @@
                 <a:solidFill>
                   <a:srgbClr val="96651A"/>
                 </a:solidFill>
-                <a:latin typeface="Poppins" pitchFamily="34" charset="0"/>
+                <a:latin typeface="Playfair Display" pitchFamily="34" charset="0"/>
                 <a:ea typeface="Arial" pitchFamily="34" charset="-122"/>
                 <a:cs typeface="Arial" pitchFamily="34" charset="-120"/>
               </a:rPr>
@@ -12474,7 +12474,7 @@
                 <a:solidFill>
                   <a:srgbClr val="151210"/>
                 </a:solidFill>
-                <a:latin typeface="Poppins" pitchFamily="34" charset="0"/>
+                <a:latin typeface="DM Sans 14pt" pitchFamily="34" charset="0"/>
                 <a:ea typeface="Arial" pitchFamily="34" charset="-122"/>
                 <a:cs typeface="Arial" pitchFamily="34" charset="-120"/>
               </a:rPr>
@@ -12491,7 +12491,7 @@
                 <a:solidFill>
                   <a:srgbClr val="151210"/>
                 </a:solidFill>
-                <a:latin typeface="Poppins" pitchFamily="34" charset="0"/>
+                <a:latin typeface="DM Sans 14pt" pitchFamily="34" charset="0"/>
                 <a:ea typeface="Arial" pitchFamily="34" charset="-122"/>
                 <a:cs typeface="Arial" pitchFamily="34" charset="-120"/>
               </a:rPr>
@@ -12508,7 +12508,7 @@
                 <a:solidFill>
                   <a:srgbClr val="151210"/>
                 </a:solidFill>
-                <a:latin typeface="Poppins" pitchFamily="34" charset="0"/>
+                <a:latin typeface="DM Sans 14pt" pitchFamily="34" charset="0"/>
                 <a:ea typeface="Arial" pitchFamily="34" charset="-122"/>
                 <a:cs typeface="Arial" pitchFamily="34" charset="-120"/>
               </a:rPr>
@@ -12576,7 +12576,7 @@
                 <a:solidFill>
                   <a:srgbClr val="151210"/>
                 </a:solidFill>
-                <a:latin typeface="Poppins" pitchFamily="34" charset="0"/>
+                <a:latin typeface="Playfair Display" pitchFamily="34" charset="0"/>
                 <a:ea typeface="Arial" pitchFamily="34" charset="-122"/>
                 <a:cs typeface="Arial" pitchFamily="34" charset="-120"/>
               </a:rPr>
@@ -12617,7 +12617,7 @@
                 <a:solidFill>
                   <a:srgbClr val="96651A"/>
                 </a:solidFill>
-                <a:latin typeface="Poppins" pitchFamily="34" charset="0"/>
+                <a:latin typeface="Playfair Display" pitchFamily="34" charset="0"/>
                 <a:ea typeface="Arial" pitchFamily="34" charset="-122"/>
                 <a:cs typeface="Arial" pitchFamily="34" charset="-120"/>
               </a:rPr>
@@ -12681,11 +12681,11 @@
               <a:buNone/>
             </a:pPr>
             <a:r>
-              <a:rPr lang="en-US" sz="1000" b="1" dirty="0">
+              <a:rPr lang="en-US" sz="1000" b="1" dirty="0" spc="60">
                 <a:solidFill>
                   <a:srgbClr val="E6BD5E"/>
                 </a:solidFill>
-                <a:latin typeface="Poppins" pitchFamily="34" charset="0"/>
+                <a:latin typeface="DM Sans 14pt" pitchFamily="34" charset="0"/>
                 <a:ea typeface="Arial" pitchFamily="34" charset="-122"/>
                 <a:cs typeface="Arial" pitchFamily="34" charset="-120"/>
               </a:rPr>
@@ -12726,7 +12726,7 @@
                 <a:solidFill>
                   <a:srgbClr val="FFFFFF"/>
                 </a:solidFill>
-                <a:latin typeface="Poppins" pitchFamily="34" charset="0"/>
+                <a:latin typeface="DM Sans 14pt" pitchFamily="34" charset="0"/>
                 <a:ea typeface="Arial" pitchFamily="34" charset="-122"/>
                 <a:cs typeface="Arial" pitchFamily="34" charset="-120"/>
               </a:rPr>

</xml_diff>